<commit_message>
Cap nhat slide thuyet trinh
</commit_message>
<xml_diff>
--- a/docs/PhamAnDung_slide_cuoiky.pptx
+++ b/docs/PhamAnDung_slide_cuoiky.pptx
@@ -2024,44 +2024,6 @@
           </a:ln>
         </p:spPr>
       </p:sp>
-      <p:sp>
-        <p:nvSpPr>
-          <p:cNvPr id="7" name="Text 5"/>
-          <p:cNvSpPr/>
-          <p:nvPr/>
-        </p:nvSpPr>
-        <p:spPr>
-          <a:xfrm>
-            <a:off x="411480" y="4828032"/>
-            <a:ext cx="5029200" cy="228600"/>
-          </a:xfrm>
-          <a:prstGeom prst="rect">
-            <a:avLst/>
-          </a:prstGeom>
-          <a:noFill/>
-        </p:spPr>
-        <p:txBody>
-          <a:bodyPr wrap="square" lIns="0" tIns="0" rIns="0" bIns="0" rtlCol="0" anchor="ctr"/>
-          <a:lstStyle/>
-          <a:p>
-            <a:pPr marL="0" indent="0">
-              <a:buNone/>
-            </a:pPr>
-            <a:r>
-              <a:rPr lang="en-US" sz="900" dirty="0">
-                <a:solidFill>
-                  <a:srgbClr val="888888"/>
-                </a:solidFill>
-                <a:latin typeface="Georgia" panose="02040502050405020303" pitchFamily="34" charset="0"/>
-                <a:ea typeface="Georgia" panose="02040502050405020303" pitchFamily="34" charset="-122"/>
-                <a:cs typeface="Georgia" panose="02040502050405020303" pitchFamily="34" charset="-120"/>
-              </a:rPr>
-              <a:t>Mạng Cảm Biến | Tháng 5 năm 2025</a:t>
-            </a:r>
-            <a:endParaRPr lang="en-US" sz="900" dirty="0"/>
-          </a:p>
-        </p:txBody>
-      </p:sp>
     </p:spTree>
   </p:cSld>
   <p:clrMapOvr>
@@ -2726,44 +2688,6 @@
           </a:p>
         </p:txBody>
       </p:sp>
-      <p:sp>
-        <p:nvSpPr>
-          <p:cNvPr id="20" name="Text 18"/>
-          <p:cNvSpPr/>
-          <p:nvPr/>
-        </p:nvSpPr>
-        <p:spPr>
-          <a:xfrm>
-            <a:off x="411480" y="4828032"/>
-            <a:ext cx="5029200" cy="228600"/>
-          </a:xfrm>
-          <a:prstGeom prst="rect">
-            <a:avLst/>
-          </a:prstGeom>
-          <a:noFill/>
-        </p:spPr>
-        <p:txBody>
-          <a:bodyPr wrap="square" lIns="0" tIns="0" rIns="0" bIns="0" rtlCol="0" anchor="ctr"/>
-          <a:lstStyle/>
-          <a:p>
-            <a:pPr marL="0" indent="0">
-              <a:buNone/>
-            </a:pPr>
-            <a:r>
-              <a:rPr lang="en-US" sz="900" dirty="0">
-                <a:solidFill>
-                  <a:srgbClr val="999999"/>
-                </a:solidFill>
-                <a:latin typeface="Georgia" panose="02040502050405020303" pitchFamily="34" charset="0"/>
-                <a:ea typeface="Georgia" panose="02040502050405020303" pitchFamily="34" charset="-122"/>
-                <a:cs typeface="Georgia" panose="02040502050405020303" pitchFamily="34" charset="-120"/>
-              </a:rPr>
-              <a:t>Mạng Cảm Biến | Tháng 5 năm 2025</a:t>
-            </a:r>
-            <a:endParaRPr lang="en-US" sz="900" dirty="0"/>
-          </a:p>
-        </p:txBody>
-      </p:sp>
     </p:spTree>
   </p:cSld>
   <p:clrMapOvr>
@@ -3300,44 +3224,6 @@
           </a:p>
         </p:txBody>
       </p:sp>
-      <p:sp>
-        <p:nvSpPr>
-          <p:cNvPr id="16" name="Text 14"/>
-          <p:cNvSpPr/>
-          <p:nvPr/>
-        </p:nvSpPr>
-        <p:spPr>
-          <a:xfrm>
-            <a:off x="411480" y="4828032"/>
-            <a:ext cx="5029200" cy="228600"/>
-          </a:xfrm>
-          <a:prstGeom prst="rect">
-            <a:avLst/>
-          </a:prstGeom>
-          <a:noFill/>
-        </p:spPr>
-        <p:txBody>
-          <a:bodyPr wrap="square" lIns="0" tIns="0" rIns="0" bIns="0" rtlCol="0" anchor="ctr"/>
-          <a:lstStyle/>
-          <a:p>
-            <a:pPr marL="0" indent="0">
-              <a:buNone/>
-            </a:pPr>
-            <a:r>
-              <a:rPr lang="en-US" sz="900" dirty="0">
-                <a:solidFill>
-                  <a:srgbClr val="888888"/>
-                </a:solidFill>
-                <a:latin typeface="Georgia" panose="02040502050405020303" pitchFamily="34" charset="0"/>
-                <a:ea typeface="Georgia" panose="02040502050405020303" pitchFamily="34" charset="-122"/>
-                <a:cs typeface="Georgia" panose="02040502050405020303" pitchFamily="34" charset="-120"/>
-              </a:rPr>
-              <a:t>Mạng Cảm Biến | Tháng 5 năm 2025</a:t>
-            </a:r>
-            <a:endParaRPr lang="en-US" sz="900" dirty="0"/>
-          </a:p>
-        </p:txBody>
-      </p:sp>
     </p:spTree>
   </p:cSld>
   <p:clrMapOvr>
@@ -3810,44 +3696,6 @@
           </a:ln>
         </p:spPr>
       </p:sp>
-      <p:sp>
-        <p:nvSpPr>
-          <p:cNvPr id="15" name="Text 13"/>
-          <p:cNvSpPr/>
-          <p:nvPr/>
-        </p:nvSpPr>
-        <p:spPr>
-          <a:xfrm>
-            <a:off x="411480" y="4828032"/>
-            <a:ext cx="5029200" cy="228600"/>
-          </a:xfrm>
-          <a:prstGeom prst="rect">
-            <a:avLst/>
-          </a:prstGeom>
-          <a:noFill/>
-        </p:spPr>
-        <p:txBody>
-          <a:bodyPr wrap="square" lIns="0" tIns="0" rIns="0" bIns="0" rtlCol="0" anchor="ctr"/>
-          <a:lstStyle/>
-          <a:p>
-            <a:pPr marL="0" indent="0">
-              <a:buNone/>
-            </a:pPr>
-            <a:r>
-              <a:rPr lang="en-US" sz="900" dirty="0">
-                <a:solidFill>
-                  <a:srgbClr val="999999"/>
-                </a:solidFill>
-                <a:latin typeface="Georgia" panose="02040502050405020303" pitchFamily="34" charset="0"/>
-                <a:ea typeface="Georgia" panose="02040502050405020303" pitchFamily="34" charset="-122"/>
-                <a:cs typeface="Georgia" panose="02040502050405020303" pitchFamily="34" charset="-120"/>
-              </a:rPr>
-              <a:t>Mạng Cảm Biến | Tháng 5 năm 2025</a:t>
-            </a:r>
-            <a:endParaRPr lang="en-US" sz="900" dirty="0"/>
-          </a:p>
-        </p:txBody>
-      </p:sp>
     </p:spTree>
   </p:cSld>
   <p:clrMapOvr>
@@ -4520,44 +4368,6 @@
           </a:p>
         </p:txBody>
       </p:sp>
-      <p:sp>
-        <p:nvSpPr>
-          <p:cNvPr id="11" name="Text 9"/>
-          <p:cNvSpPr/>
-          <p:nvPr/>
-        </p:nvSpPr>
-        <p:spPr>
-          <a:xfrm>
-            <a:off x="411480" y="4828032"/>
-            <a:ext cx="5029200" cy="228600"/>
-          </a:xfrm>
-          <a:prstGeom prst="rect">
-            <a:avLst/>
-          </a:prstGeom>
-          <a:noFill/>
-        </p:spPr>
-        <p:txBody>
-          <a:bodyPr wrap="square" lIns="0" tIns="0" rIns="0" bIns="0" rtlCol="0" anchor="ctr"/>
-          <a:lstStyle/>
-          <a:p>
-            <a:pPr marL="0" indent="0">
-              <a:buNone/>
-            </a:pPr>
-            <a:r>
-              <a:rPr lang="en-US" sz="900" dirty="0">
-                <a:solidFill>
-                  <a:srgbClr val="999999"/>
-                </a:solidFill>
-                <a:latin typeface="Georgia" panose="02040502050405020303" pitchFamily="34" charset="0"/>
-                <a:ea typeface="Georgia" panose="02040502050405020303" pitchFamily="34" charset="-122"/>
-                <a:cs typeface="Georgia" panose="02040502050405020303" pitchFamily="34" charset="-120"/>
-              </a:rPr>
-              <a:t>Mạng Cảm Biến | Tháng 5 năm 2025</a:t>
-            </a:r>
-            <a:endParaRPr lang="en-US" sz="900" dirty="0"/>
-          </a:p>
-        </p:txBody>
-      </p:sp>
     </p:spTree>
   </p:cSld>
   <p:clrMapOvr>
@@ -5443,44 +5253,6 @@
               <a:t>Ứng dụng thực tiễn cao trong nhà thông minh và điều khiển thiết bị.</a:t>
             </a:r>
             <a:endParaRPr lang="en-US" sz="1400" dirty="0"/>
-          </a:p>
-        </p:txBody>
-      </p:sp>
-      <p:sp>
-        <p:nvSpPr>
-          <p:cNvPr id="26" name="Text 24"/>
-          <p:cNvSpPr/>
-          <p:nvPr/>
-        </p:nvSpPr>
-        <p:spPr>
-          <a:xfrm>
-            <a:off x="5029200" y="4828032"/>
-            <a:ext cx="3840480" cy="228600"/>
-          </a:xfrm>
-          <a:prstGeom prst="rect">
-            <a:avLst/>
-          </a:prstGeom>
-          <a:noFill/>
-        </p:spPr>
-        <p:txBody>
-          <a:bodyPr wrap="square" lIns="0" tIns="0" rIns="0" bIns="0" rtlCol="0" anchor="ctr"/>
-          <a:lstStyle/>
-          <a:p>
-            <a:pPr marL="0" indent="0" algn="r">
-              <a:buNone/>
-            </a:pPr>
-            <a:r>
-              <a:rPr lang="en-US" sz="900" dirty="0">
-                <a:solidFill>
-                  <a:srgbClr val="888888"/>
-                </a:solidFill>
-                <a:latin typeface="Georgia" panose="02040502050405020303" pitchFamily="34" charset="0"/>
-                <a:ea typeface="Georgia" panose="02040502050405020303" pitchFamily="34" charset="-122"/>
-                <a:cs typeface="Georgia" panose="02040502050405020303" pitchFamily="34" charset="-120"/>
-              </a:rPr>
-              <a:t>Mạng Cảm Biến | Tháng 5 năm 2025</a:t>
-            </a:r>
-            <a:endParaRPr lang="en-US" sz="900" dirty="0"/>
           </a:p>
         </p:txBody>
       </p:sp>
@@ -6093,44 +5865,6 @@
           </a:ln>
         </p:spPr>
       </p:sp>
-      <p:sp>
-        <p:nvSpPr>
-          <p:cNvPr id="17" name="Text 15"/>
-          <p:cNvSpPr/>
-          <p:nvPr/>
-        </p:nvSpPr>
-        <p:spPr>
-          <a:xfrm>
-            <a:off x="411480" y="4828032"/>
-            <a:ext cx="5029200" cy="228600"/>
-          </a:xfrm>
-          <a:prstGeom prst="rect">
-            <a:avLst/>
-          </a:prstGeom>
-          <a:noFill/>
-        </p:spPr>
-        <p:txBody>
-          <a:bodyPr wrap="square" lIns="0" tIns="0" rIns="0" bIns="0" rtlCol="0" anchor="ctr"/>
-          <a:lstStyle/>
-          <a:p>
-            <a:pPr marL="0" indent="0">
-              <a:buNone/>
-            </a:pPr>
-            <a:r>
-              <a:rPr lang="en-US" sz="900" dirty="0">
-                <a:solidFill>
-                  <a:srgbClr val="999999"/>
-                </a:solidFill>
-                <a:latin typeface="Georgia" panose="02040502050405020303" pitchFamily="34" charset="0"/>
-                <a:ea typeface="Georgia" panose="02040502050405020303" pitchFamily="34" charset="-122"/>
-                <a:cs typeface="Georgia" panose="02040502050405020303" pitchFamily="34" charset="-120"/>
-              </a:rPr>
-              <a:t>Mạng Cảm Biến | Tháng 5 năm 2025</a:t>
-            </a:r>
-            <a:endParaRPr lang="en-US" sz="900" dirty="0"/>
-          </a:p>
-        </p:txBody>
-      </p:sp>
     </p:spTree>
   </p:cSld>
   <p:clrMapOvr>
@@ -6912,44 +6646,6 @@
           </a:p>
         </p:txBody>
       </p:sp>
-      <p:sp>
-        <p:nvSpPr>
-          <p:cNvPr id="23" name="Text 21"/>
-          <p:cNvSpPr/>
-          <p:nvPr/>
-        </p:nvSpPr>
-        <p:spPr>
-          <a:xfrm>
-            <a:off x="411480" y="4828032"/>
-            <a:ext cx="5029200" cy="228600"/>
-          </a:xfrm>
-          <a:prstGeom prst="rect">
-            <a:avLst/>
-          </a:prstGeom>
-          <a:noFill/>
-        </p:spPr>
-        <p:txBody>
-          <a:bodyPr wrap="square" lIns="0" tIns="0" rIns="0" bIns="0" rtlCol="0" anchor="ctr"/>
-          <a:lstStyle/>
-          <a:p>
-            <a:pPr marL="0" indent="0">
-              <a:buNone/>
-            </a:pPr>
-            <a:r>
-              <a:rPr lang="en-US" sz="900" dirty="0">
-                <a:solidFill>
-                  <a:srgbClr val="888888"/>
-                </a:solidFill>
-                <a:latin typeface="Georgia" panose="02040502050405020303" pitchFamily="34" charset="0"/>
-                <a:ea typeface="Georgia" panose="02040502050405020303" pitchFamily="34" charset="-122"/>
-                <a:cs typeface="Georgia" panose="02040502050405020303" pitchFamily="34" charset="-120"/>
-              </a:rPr>
-              <a:t>Mạng Cảm Biến | Tháng 5 năm 2025</a:t>
-            </a:r>
-            <a:endParaRPr lang="en-US" sz="900" dirty="0"/>
-          </a:p>
-        </p:txBody>
-      </p:sp>
     </p:spTree>
   </p:cSld>
   <p:clrMapOvr>
@@ -8081,44 +7777,6 @@
           </a:ln>
         </p:spPr>
       </p:sp>
-      <p:sp>
-        <p:nvSpPr>
-          <p:cNvPr id="32" name="Text 30"/>
-          <p:cNvSpPr/>
-          <p:nvPr/>
-        </p:nvSpPr>
-        <p:spPr>
-          <a:xfrm>
-            <a:off x="411480" y="4828032"/>
-            <a:ext cx="5029200" cy="228600"/>
-          </a:xfrm>
-          <a:prstGeom prst="rect">
-            <a:avLst/>
-          </a:prstGeom>
-          <a:noFill/>
-        </p:spPr>
-        <p:txBody>
-          <a:bodyPr wrap="square" lIns="0" tIns="0" rIns="0" bIns="0" rtlCol="0" anchor="ctr"/>
-          <a:lstStyle/>
-          <a:p>
-            <a:pPr marL="0" indent="0">
-              <a:buNone/>
-            </a:pPr>
-            <a:r>
-              <a:rPr lang="en-US" sz="900" dirty="0">
-                <a:solidFill>
-                  <a:srgbClr val="999999"/>
-                </a:solidFill>
-                <a:latin typeface="Georgia" panose="02040502050405020303" pitchFamily="34" charset="0"/>
-                <a:ea typeface="Georgia" panose="02040502050405020303" pitchFamily="34" charset="-122"/>
-                <a:cs typeface="Georgia" panose="02040502050405020303" pitchFamily="34" charset="-120"/>
-              </a:rPr>
-              <a:t>Mạng Cảm Biến | Tháng 5 năm 2025</a:t>
-            </a:r>
-            <a:endParaRPr lang="en-US" sz="900" dirty="0"/>
-          </a:p>
-        </p:txBody>
-      </p:sp>
     </p:spTree>
   </p:cSld>
   <p:clrMapOvr>
@@ -9114,44 +8772,6 @@
           </a:ln>
         </p:spPr>
       </p:sp>
-      <p:sp>
-        <p:nvSpPr>
-          <p:cNvPr id="28" name="Text 26"/>
-          <p:cNvSpPr/>
-          <p:nvPr/>
-        </p:nvSpPr>
-        <p:spPr>
-          <a:xfrm>
-            <a:off x="411480" y="4828032"/>
-            <a:ext cx="5029200" cy="228600"/>
-          </a:xfrm>
-          <a:prstGeom prst="rect">
-            <a:avLst/>
-          </a:prstGeom>
-          <a:noFill/>
-        </p:spPr>
-        <p:txBody>
-          <a:bodyPr wrap="square" lIns="0" tIns="0" rIns="0" bIns="0" rtlCol="0" anchor="ctr"/>
-          <a:lstStyle/>
-          <a:p>
-            <a:pPr marL="0" indent="0">
-              <a:buNone/>
-            </a:pPr>
-            <a:r>
-              <a:rPr lang="en-US" sz="900" dirty="0">
-                <a:solidFill>
-                  <a:srgbClr val="888888"/>
-                </a:solidFill>
-                <a:latin typeface="Georgia" panose="02040502050405020303" pitchFamily="34" charset="0"/>
-                <a:ea typeface="Georgia" panose="02040502050405020303" pitchFamily="34" charset="-122"/>
-                <a:cs typeface="Georgia" panose="02040502050405020303" pitchFamily="34" charset="-120"/>
-              </a:rPr>
-              <a:t>Mạng Cảm Biến | Tháng 5 năm 2025</a:t>
-            </a:r>
-            <a:endParaRPr lang="en-US" sz="900" dirty="0"/>
-          </a:p>
-        </p:txBody>
-      </p:sp>
     </p:spTree>
   </p:cSld>
   <p:clrMapOvr>
@@ -10314,44 +9934,6 @@
               <a:t>0.83</a:t>
             </a:r>
             <a:endParaRPr lang="en-US" sz="1200" dirty="0"/>
-          </a:p>
-        </p:txBody>
-      </p:sp>
-      <p:sp>
-        <p:nvSpPr>
-          <p:cNvPr id="36" name="Text 33"/>
-          <p:cNvSpPr/>
-          <p:nvPr/>
-        </p:nvSpPr>
-        <p:spPr>
-          <a:xfrm>
-            <a:off x="411480" y="4828032"/>
-            <a:ext cx="5029200" cy="228600"/>
-          </a:xfrm>
-          <a:prstGeom prst="rect">
-            <a:avLst/>
-          </a:prstGeom>
-          <a:noFill/>
-        </p:spPr>
-        <p:txBody>
-          <a:bodyPr wrap="square" lIns="0" tIns="0" rIns="0" bIns="0" rtlCol="0" anchor="ctr"/>
-          <a:lstStyle/>
-          <a:p>
-            <a:pPr marL="0" indent="0">
-              <a:buNone/>
-            </a:pPr>
-            <a:r>
-              <a:rPr lang="en-US" sz="900" dirty="0">
-                <a:solidFill>
-                  <a:srgbClr val="999999"/>
-                </a:solidFill>
-                <a:latin typeface="Georgia" panose="02040502050405020303" pitchFamily="34" charset="0"/>
-                <a:ea typeface="Georgia" panose="02040502050405020303" pitchFamily="34" charset="-122"/>
-                <a:cs typeface="Georgia" panose="02040502050405020303" pitchFamily="34" charset="-120"/>
-              </a:rPr>
-              <a:t>Mạng Cảm Biến | Tháng 5 năm 2025</a:t>
-            </a:r>
-            <a:endParaRPr lang="en-US" sz="900" dirty="0"/>
           </a:p>
         </p:txBody>
       </p:sp>

</xml_diff>

<commit_message>
Cap nhat slide va word
</commit_message>
<xml_diff>
--- a/docs/PhamAnDung_slide_cuoiky.pptx
+++ b/docs/PhamAnDung_slide_cuoiky.pptx
@@ -1841,6 +1841,10 @@
             <a:prstDash val="solid"/>
           </a:ln>
         </p:spPr>
+        <p:txBody>
+          <a:bodyPr/>
+          <a:p/>
+        </p:txBody>
       </p:sp>
       <p:sp>
         <p:nvSpPr>
@@ -2023,6 +2027,10 @@
             <a:prstDash val="solid"/>
           </a:ln>
         </p:spPr>
+        <p:txBody>
+          <a:bodyPr/>
+          <a:p/>
+        </p:txBody>
       </p:sp>
     </p:spTree>
   </p:cSld>
@@ -2119,6 +2127,10 @@
             <a:prstDash val="solid"/>
           </a:ln>
         </p:spPr>
+        <p:txBody>
+          <a:bodyPr/>
+          <a:p/>
+        </p:txBody>
       </p:sp>
       <p:sp>
         <p:nvSpPr>
@@ -2151,13 +2163,16 @@
                 <a:solidFill>
                   <a:srgbClr val="FFFFFF"/>
                 </a:solidFill>
-                <a:latin typeface="Georgia" panose="02040502050405020303" pitchFamily="34" charset="0"/>
-                <a:ea typeface="Georgia" panose="02040502050405020303" pitchFamily="34" charset="-122"/>
-                <a:cs typeface="Georgia" panose="02040502050405020303" pitchFamily="34" charset="-120"/>
+                <a:latin typeface="Times New Roman" panose="02020603050405020304" charset="0"/>
+                <a:ea typeface="Georgia" panose="02040502050405020303" pitchFamily="34" charset="-122"/>
+                <a:cs typeface="Times New Roman" panose="02020603050405020304" charset="0"/>
               </a:rPr>
               <a:t>Demo</a:t>
             </a:r>
-            <a:endParaRPr lang="en-US" sz="4400" dirty="0"/>
+            <a:endParaRPr lang="en-US" sz="4400" dirty="0">
+              <a:latin typeface="Times New Roman" panose="02020603050405020304" charset="0"/>
+              <a:cs typeface="Times New Roman" panose="02020603050405020304" charset="0"/>
+            </a:endParaRPr>
           </a:p>
           <a:p>
             <a:pPr marL="0" indent="0">
@@ -2171,13 +2186,16 @@
                 <a:solidFill>
                   <a:srgbClr val="FFFFFF"/>
                 </a:solidFill>
-                <a:latin typeface="Georgia" panose="02040502050405020303" pitchFamily="34" charset="0"/>
-                <a:ea typeface="Georgia" panose="02040502050405020303" pitchFamily="34" charset="-122"/>
-                <a:cs typeface="Georgia" panose="02040502050405020303" pitchFamily="34" charset="-120"/>
+                <a:latin typeface="Times New Roman" panose="02020603050405020304" charset="0"/>
+                <a:ea typeface="Georgia" panose="02040502050405020303" pitchFamily="34" charset="-122"/>
+                <a:cs typeface="Times New Roman" panose="02020603050405020304" charset="0"/>
               </a:rPr>
               <a:t>thời gian thực</a:t>
             </a:r>
-            <a:endParaRPr lang="en-US" sz="4400" dirty="0"/>
+            <a:endParaRPr lang="en-US" sz="4400" dirty="0">
+              <a:latin typeface="Times New Roman" panose="02020603050405020304" charset="0"/>
+              <a:cs typeface="Times New Roman" panose="02020603050405020304" charset="0"/>
+            </a:endParaRPr>
           </a:p>
         </p:txBody>
       </p:sp>
@@ -2247,13 +2265,16 @@
                 <a:solidFill>
                   <a:srgbClr val="FFFFFF"/>
                 </a:solidFill>
-                <a:latin typeface="Georgia" panose="02040502050405020303" pitchFamily="34" charset="0"/>
-                <a:ea typeface="Georgia" panose="02040502050405020303" pitchFamily="34" charset="-122"/>
-                <a:cs typeface="Georgia" panose="02040502050405020303" pitchFamily="34" charset="-120"/>
+                <a:latin typeface="Times New Roman" panose="02020603050405020304" charset="0"/>
+                <a:ea typeface="Georgia" panose="02040502050405020303" pitchFamily="34" charset="-122"/>
+                <a:cs typeface="Times New Roman" panose="02020603050405020304" charset="0"/>
               </a:rPr>
               <a:t>Deployment → WebAssembly → Build</a:t>
             </a:r>
-            <a:endParaRPr lang="en-US" sz="1600" dirty="0"/>
+            <a:endParaRPr lang="en-US" sz="1600" dirty="0">
+              <a:latin typeface="Times New Roman" panose="02020603050405020304" charset="0"/>
+              <a:cs typeface="Times New Roman" panose="02020603050405020304" charset="0"/>
+            </a:endParaRPr>
           </a:p>
         </p:txBody>
       </p:sp>
@@ -2281,6 +2302,10 @@
             <a:prstDash val="solid"/>
           </a:ln>
         </p:spPr>
+        <p:txBody>
+          <a:bodyPr/>
+          <a:p/>
+        </p:txBody>
       </p:sp>
       <p:sp>
         <p:nvSpPr>
@@ -2348,13 +2373,16 @@
                 <a:solidFill>
                   <a:srgbClr val="FFFFFF"/>
                 </a:solidFill>
-                <a:latin typeface="Georgia" panose="02040502050405020303" pitchFamily="34" charset="0"/>
-                <a:ea typeface="Georgia" panose="02040502050405020303" pitchFamily="34" charset="-122"/>
-                <a:cs typeface="Georgia" panose="02040502050405020303" pitchFamily="34" charset="-120"/>
+                <a:latin typeface="Times New Roman" panose="02020603050405020304" charset="0"/>
+                <a:ea typeface="Georgia" panose="02040502050405020303" pitchFamily="34" charset="-122"/>
+                <a:cs typeface="Times New Roman" panose="02020603050405020304" charset="0"/>
               </a:rPr>
               <a:t>Launch in browser → cho phép camera</a:t>
             </a:r>
-            <a:endParaRPr lang="en-US" sz="1600" dirty="0"/>
+            <a:endParaRPr lang="en-US" sz="1600" dirty="0">
+              <a:latin typeface="Times New Roman" panose="02020603050405020304" charset="0"/>
+              <a:cs typeface="Times New Roman" panose="02020603050405020304" charset="0"/>
+            </a:endParaRPr>
           </a:p>
         </p:txBody>
       </p:sp>
@@ -2382,6 +2410,10 @@
             <a:prstDash val="solid"/>
           </a:ln>
         </p:spPr>
+        <p:txBody>
+          <a:bodyPr/>
+          <a:p/>
+        </p:txBody>
       </p:sp>
       <p:sp>
         <p:nvSpPr>
@@ -2449,13 +2481,20 @@
                 <a:solidFill>
                   <a:srgbClr val="FFFFFF"/>
                 </a:solidFill>
-                <a:latin typeface="Georgia" panose="02040502050405020303" pitchFamily="34" charset="0"/>
-                <a:ea typeface="Georgia" panose="02040502050405020303" pitchFamily="34" charset="-122"/>
-                <a:cs typeface="Georgia" panose="02040502050405020303" pitchFamily="34" charset="-120"/>
+                <a:latin typeface="Times New Roman" panose="02020603050405020304" charset="0"/>
+                <a:ea typeface="Georgia" panose="02040502050405020303" pitchFamily="34" charset="-122"/>
+                <a:cs typeface="Times New Roman" panose="02020603050405020304" charset="0"/>
               </a:rPr>
               <a:t>Thực hiện 4 cử chỉ trước webcam</a:t>
             </a:r>
-            <a:endParaRPr lang="en-US" sz="1600" dirty="0"/>
+            <a:endParaRPr lang="en-US" sz="1600" dirty="0">
+              <a:solidFill>
+                <a:srgbClr val="FFFFFF"/>
+              </a:solidFill>
+              <a:latin typeface="Times New Roman" panose="02020603050405020304" charset="0"/>
+              <a:ea typeface="Georgia" panose="02040502050405020303" pitchFamily="34" charset="-122"/>
+              <a:cs typeface="Times New Roman" panose="02020603050405020304" charset="0"/>
+            </a:endParaRPr>
           </a:p>
         </p:txBody>
       </p:sp>
@@ -2483,6 +2522,10 @@
             <a:prstDash val="solid"/>
           </a:ln>
         </p:spPr>
+        <p:txBody>
+          <a:bodyPr/>
+          <a:p/>
+        </p:txBody>
       </p:sp>
       <p:sp>
         <p:nvSpPr>
@@ -2550,13 +2593,20 @@
                 <a:solidFill>
                   <a:srgbClr val="FFFFFF"/>
                 </a:solidFill>
-                <a:latin typeface="Georgia" panose="02040502050405020303" pitchFamily="34" charset="0"/>
-                <a:ea typeface="Georgia" panose="02040502050405020303" pitchFamily="34" charset="-122"/>
-                <a:cs typeface="Georgia" panose="02040502050405020303" pitchFamily="34" charset="-120"/>
+                <a:latin typeface="Times New Roman" panose="02020603050405020304" charset="0"/>
+                <a:ea typeface="Georgia" panose="02040502050405020303" pitchFamily="34" charset="-122"/>
+                <a:cs typeface="Times New Roman" panose="02020603050405020304" charset="0"/>
               </a:rPr>
               <a:t>Quan sát kết quả nhận diện realtime</a:t>
             </a:r>
-            <a:endParaRPr lang="en-US" sz="1600" dirty="0"/>
+            <a:endParaRPr lang="en-US" sz="1600" dirty="0">
+              <a:solidFill>
+                <a:srgbClr val="FFFFFF"/>
+              </a:solidFill>
+              <a:latin typeface="Times New Roman" panose="02020603050405020304" charset="0"/>
+              <a:ea typeface="Georgia" panose="02040502050405020303" pitchFamily="34" charset="-122"/>
+              <a:cs typeface="Times New Roman" panose="02020603050405020304" charset="0"/>
+            </a:endParaRPr>
           </a:p>
         </p:txBody>
       </p:sp>
@@ -2584,6 +2634,10 @@
             <a:prstDash val="solid"/>
           </a:ln>
         </p:spPr>
+        <p:txBody>
+          <a:bodyPr/>
+          <a:p/>
+        </p:txBody>
       </p:sp>
       <p:sp>
         <p:nvSpPr>
@@ -2643,21 +2697,23 @@
           <a:bodyPr wrap="square" lIns="0" tIns="0" rIns="0" bIns="0" rtlCol="0" anchor="ctr"/>
           <a:lstStyle/>
           <a:p>
-            <a:pPr marL="0" indent="0">
-              <a:buNone/>
-            </a:pPr>
-            <a:r>
-              <a:rPr lang="en-US" sz="1200" dirty="0">
-                <a:solidFill>
-                  <a:srgbClr val="FFFFFF"/>
-                </a:solidFill>
-                <a:latin typeface="Georgia" panose="02040502050405020303" pitchFamily="34" charset="0"/>
-                <a:ea typeface="Georgia" panose="02040502050405020303" pitchFamily="34" charset="-122"/>
-                <a:cs typeface="Georgia" panose="02040502050405020303" pitchFamily="34" charset="-120"/>
+            <a:r>
+              <a:rPr lang="en-US" altLang="en-US">
+                <a:solidFill>
+                  <a:schemeClr val="bg1"/>
+                </a:solidFill>
+                <a:latin typeface="Times New Roman" panose="02020603050405020304" charset="0"/>
+                <a:cs typeface="Times New Roman" panose="02020603050405020304" charset="0"/>
               </a:rPr>
               <a:t>https://studio.edgeimpulse.com/studio/1013348</a:t>
             </a:r>
-            <a:endParaRPr lang="en-US" sz="1200" dirty="0"/>
+            <a:endParaRPr lang="en-US" altLang="en-US">
+              <a:solidFill>
+                <a:schemeClr val="bg1"/>
+              </a:solidFill>
+              <a:latin typeface="Times New Roman" panose="02020603050405020304" charset="0"/>
+              <a:cs typeface="Times New Roman" panose="02020603050405020304" charset="0"/>
+            </a:endParaRPr>
           </a:p>
         </p:txBody>
       </p:sp>
@@ -2783,6 +2839,10 @@
             <a:prstDash val="solid"/>
           </a:ln>
         </p:spPr>
+        <p:txBody>
+          <a:bodyPr/>
+          <a:p/>
+        </p:txBody>
       </p:sp>
       <p:sp>
         <p:nvSpPr>
@@ -2815,13 +2875,16 @@
                 <a:solidFill>
                   <a:srgbClr val="111111"/>
                 </a:solidFill>
-                <a:latin typeface="Georgia" panose="02040502050405020303" pitchFamily="34" charset="0"/>
-                <a:ea typeface="Georgia" panose="02040502050405020303" pitchFamily="34" charset="-122"/>
-                <a:cs typeface="Georgia" panose="02040502050405020303" pitchFamily="34" charset="-120"/>
+                <a:latin typeface="Times New Roman" panose="02020603050405020304" charset="0"/>
+                <a:ea typeface="Georgia" panose="02040502050405020303" pitchFamily="34" charset="-122"/>
+                <a:cs typeface="Times New Roman" panose="02020603050405020304" charset="0"/>
               </a:rPr>
               <a:t>Kết luận &amp;</a:t>
             </a:r>
-            <a:endParaRPr lang="en-US" sz="4400" dirty="0"/>
+            <a:endParaRPr lang="en-US" sz="4400" dirty="0">
+              <a:latin typeface="Times New Roman" panose="02020603050405020304" charset="0"/>
+              <a:cs typeface="Times New Roman" panose="02020603050405020304" charset="0"/>
+            </a:endParaRPr>
           </a:p>
           <a:p>
             <a:pPr marL="0" indent="0">
@@ -2835,13 +2898,16 @@
                 <a:solidFill>
                   <a:srgbClr val="111111"/>
                 </a:solidFill>
-                <a:latin typeface="Georgia" panose="02040502050405020303" pitchFamily="34" charset="0"/>
-                <a:ea typeface="Georgia" panose="02040502050405020303" pitchFamily="34" charset="-122"/>
-                <a:cs typeface="Georgia" panose="02040502050405020303" pitchFamily="34" charset="-120"/>
+                <a:latin typeface="Times New Roman" panose="02020603050405020304" charset="0"/>
+                <a:ea typeface="Georgia" panose="02040502050405020303" pitchFamily="34" charset="-122"/>
+                <a:cs typeface="Times New Roman" panose="02020603050405020304" charset="0"/>
               </a:rPr>
               <a:t>Hướng phát triển</a:t>
             </a:r>
-            <a:endParaRPr lang="en-US" sz="4400" dirty="0"/>
+            <a:endParaRPr lang="en-US" sz="4400" dirty="0">
+              <a:latin typeface="Times New Roman" panose="02020603050405020304" charset="0"/>
+              <a:cs typeface="Times New Roman" panose="02020603050405020304" charset="0"/>
+            </a:endParaRPr>
           </a:p>
         </p:txBody>
       </p:sp>
@@ -2871,15 +2937,22 @@
             <a:r>
               <a:rPr lang="en-US" sz="1200" dirty="0">
                 <a:solidFill>
-                  <a:srgbClr val="888888"/>
-                </a:solidFill>
-                <a:latin typeface="Georgia" panose="02040502050405020303" pitchFamily="34" charset="0"/>
-                <a:ea typeface="Georgia" panose="02040502050405020303" pitchFamily="34" charset="-122"/>
-                <a:cs typeface="Georgia" panose="02040502050405020303" pitchFamily="34" charset="-120"/>
+                  <a:schemeClr val="tx1"/>
+                </a:solidFill>
+                <a:latin typeface="Times New Roman" panose="02020603050405020304" charset="0"/>
+                <a:ea typeface="Georgia" panose="02040502050405020303" pitchFamily="34" charset="-122"/>
+                <a:cs typeface="Times New Roman" panose="02020603050405020304" charset="0"/>
               </a:rPr>
               <a:t>Đã đạt được</a:t>
             </a:r>
-            <a:endParaRPr lang="en-US" sz="1200" dirty="0"/>
+            <a:endParaRPr lang="en-US" sz="1200" dirty="0">
+              <a:solidFill>
+                <a:schemeClr val="tx1"/>
+              </a:solidFill>
+              <a:latin typeface="Times New Roman" panose="02020603050405020304" charset="0"/>
+              <a:ea typeface="Georgia" panose="02040502050405020303" pitchFamily="34" charset="-122"/>
+              <a:cs typeface="Times New Roman" panose="02020603050405020304" charset="0"/>
+            </a:endParaRPr>
           </a:p>
         </p:txBody>
       </p:sp>
@@ -2915,9 +2988,27 @@
                 <a:ea typeface="Georgia" panose="02040502050405020303" pitchFamily="34" charset="-122"/>
                 <a:cs typeface="Georgia" panose="02040502050405020303" pitchFamily="34" charset="-120"/>
               </a:rPr>
-              <a:t>—  Accuracy 87.5% và F1 = 0.88 – đạt yêu cầu ≥ 0.85</a:t>
-            </a:r>
-            <a:endParaRPr lang="en-US" sz="1400" dirty="0"/>
+              <a:t>—  </a:t>
+            </a:r>
+            <a:r>
+              <a:rPr lang="en-US" sz="1400" dirty="0">
+                <a:solidFill>
+                  <a:srgbClr val="111111"/>
+                </a:solidFill>
+                <a:latin typeface="Times New Roman" panose="02020603050405020304" charset="0"/>
+                <a:ea typeface="Georgia" panose="02040502050405020303" pitchFamily="34" charset="-122"/>
+                <a:cs typeface="Times New Roman" panose="02020603050405020304" charset="0"/>
+              </a:rPr>
+              <a:t>Accuracy 87.5% và F1 = 0.88 – đạt yêu cầu ≥ 0.85</a:t>
+            </a:r>
+            <a:endParaRPr lang="en-US" sz="1400" dirty="0">
+              <a:solidFill>
+                <a:srgbClr val="111111"/>
+              </a:solidFill>
+              <a:latin typeface="Times New Roman" panose="02020603050405020304" charset="0"/>
+              <a:ea typeface="Georgia" panose="02040502050405020303" pitchFamily="34" charset="-122"/>
+              <a:cs typeface="Times New Roman" panose="02020603050405020304" charset="0"/>
+            </a:endParaRPr>
           </a:p>
         </p:txBody>
       </p:sp>
@@ -2945,6 +3036,10 @@
             <a:prstDash val="solid"/>
           </a:ln>
         </p:spPr>
+        <p:txBody>
+          <a:bodyPr/>
+          <a:p/>
+        </p:txBody>
       </p:sp>
       <p:sp>
         <p:nvSpPr>
@@ -2978,9 +3073,27 @@
                 <a:ea typeface="Georgia" panose="02040502050405020303" pitchFamily="34" charset="-122"/>
                 <a:cs typeface="Georgia" panose="02040502050405020303" pitchFamily="34" charset="-120"/>
               </a:rPr>
-              <a:t>—  Xây dựng thành công pipeline TinyML end-to-end trên Edge Impulse</a:t>
-            </a:r>
-            <a:endParaRPr lang="en-US" sz="1400" dirty="0"/>
+              <a:t>—  </a:t>
+            </a:r>
+            <a:r>
+              <a:rPr lang="en-US" sz="1400" dirty="0">
+                <a:solidFill>
+                  <a:srgbClr val="111111"/>
+                </a:solidFill>
+                <a:latin typeface="Times New Roman" panose="02020603050405020304" charset="0"/>
+                <a:ea typeface="Georgia" panose="02040502050405020303" pitchFamily="34" charset="-122"/>
+                <a:cs typeface="Times New Roman" panose="02020603050405020304" charset="0"/>
+              </a:rPr>
+              <a:t>Xây dựng thành công pipeline TinyML end-to-end trên Edge Impulse</a:t>
+            </a:r>
+            <a:endParaRPr lang="en-US" sz="1400" dirty="0">
+              <a:solidFill>
+                <a:srgbClr val="111111"/>
+              </a:solidFill>
+              <a:latin typeface="Times New Roman" panose="02020603050405020304" charset="0"/>
+              <a:ea typeface="Georgia" panose="02040502050405020303" pitchFamily="34" charset="-122"/>
+              <a:cs typeface="Times New Roman" panose="02020603050405020304" charset="0"/>
+            </a:endParaRPr>
           </a:p>
         </p:txBody>
       </p:sp>
@@ -3008,6 +3121,10 @@
             <a:prstDash val="solid"/>
           </a:ln>
         </p:spPr>
+        <p:txBody>
+          <a:bodyPr/>
+          <a:p/>
+        </p:txBody>
       </p:sp>
       <p:sp>
         <p:nvSpPr>
@@ -3041,9 +3158,27 @@
                 <a:ea typeface="Georgia" panose="02040502050405020303" pitchFamily="34" charset="-122"/>
                 <a:cs typeface="Georgia" panose="02040502050405020303" pitchFamily="34" charset="-120"/>
               </a:rPr>
-              <a:t>—  Triển khai WebAssembly, kiểm thử realtime trên trình duyệt</a:t>
-            </a:r>
-            <a:endParaRPr lang="en-US" sz="1400" dirty="0"/>
+              <a:t>—  </a:t>
+            </a:r>
+            <a:r>
+              <a:rPr lang="en-US" sz="1400" dirty="0">
+                <a:solidFill>
+                  <a:srgbClr val="111111"/>
+                </a:solidFill>
+                <a:latin typeface="Times New Roman" panose="02020603050405020304" charset="0"/>
+                <a:ea typeface="Georgia" panose="02040502050405020303" pitchFamily="34" charset="-122"/>
+                <a:cs typeface="Times New Roman" panose="02020603050405020304" charset="0"/>
+              </a:rPr>
+              <a:t>Triển khai WebAssembly, kiểm thử realtime trên trình duyệt</a:t>
+            </a:r>
+            <a:endParaRPr lang="en-US" sz="1400" dirty="0">
+              <a:solidFill>
+                <a:srgbClr val="111111"/>
+              </a:solidFill>
+              <a:latin typeface="Times New Roman" panose="02020603050405020304" charset="0"/>
+              <a:ea typeface="Georgia" panose="02040502050405020303" pitchFamily="34" charset="-122"/>
+              <a:cs typeface="Times New Roman" panose="02020603050405020304" charset="0"/>
+            </a:endParaRPr>
           </a:p>
         </p:txBody>
       </p:sp>
@@ -3071,6 +3206,10 @@
             <a:prstDash val="solid"/>
           </a:ln>
         </p:spPr>
+        <p:txBody>
+          <a:bodyPr/>
+          <a:p/>
+        </p:txBody>
       </p:sp>
       <p:sp>
         <p:nvSpPr>
@@ -3098,15 +3237,22 @@
             <a:r>
               <a:rPr lang="en-US" sz="1200" dirty="0">
                 <a:solidFill>
-                  <a:srgbClr val="888888"/>
-                </a:solidFill>
-                <a:latin typeface="Georgia" panose="02040502050405020303" pitchFamily="34" charset="0"/>
-                <a:ea typeface="Georgia" panose="02040502050405020303" pitchFamily="34" charset="-122"/>
-                <a:cs typeface="Georgia" panose="02040502050405020303" pitchFamily="34" charset="-120"/>
+                  <a:schemeClr val="tx1"/>
+                </a:solidFill>
+                <a:latin typeface="Times New Roman" panose="02020603050405020304" charset="0"/>
+                <a:ea typeface="Georgia" panose="02040502050405020303" pitchFamily="34" charset="-122"/>
+                <a:cs typeface="Times New Roman" panose="02020603050405020304" charset="0"/>
               </a:rPr>
               <a:t>Hướng phát triển</a:t>
             </a:r>
-            <a:endParaRPr lang="en-US" sz="1200" dirty="0"/>
+            <a:endParaRPr lang="en-US" sz="1200" dirty="0">
+              <a:solidFill>
+                <a:schemeClr val="tx1"/>
+              </a:solidFill>
+              <a:latin typeface="Times New Roman" panose="02020603050405020304" charset="0"/>
+              <a:ea typeface="Georgia" panose="02040502050405020303" pitchFamily="34" charset="-122"/>
+              <a:cs typeface="Times New Roman" panose="02020603050405020304" charset="0"/>
+            </a:endParaRPr>
           </a:p>
         </p:txBody>
       </p:sp>
@@ -3142,9 +3288,27 @@
                 <a:ea typeface="Georgia" panose="02040502050405020303" pitchFamily="34" charset="-122"/>
                 <a:cs typeface="Georgia" panose="02040502050405020303" pitchFamily="34" charset="-120"/>
               </a:rPr>
-              <a:t>→  Mở rộng cử chỉ: ngôn ngữ ký hiệu, số đếm 1–5</a:t>
-            </a:r>
-            <a:endParaRPr lang="en-US" sz="1250" dirty="0"/>
+              <a:t>→  </a:t>
+            </a:r>
+            <a:r>
+              <a:rPr lang="en-US" sz="1250" dirty="0">
+                <a:solidFill>
+                  <a:schemeClr val="tx1"/>
+                </a:solidFill>
+                <a:latin typeface="Times New Roman" panose="02020603050405020304" charset="0"/>
+                <a:ea typeface="Georgia" panose="02040502050405020303" pitchFamily="34" charset="-122"/>
+                <a:cs typeface="Times New Roman" panose="02020603050405020304" charset="0"/>
+              </a:rPr>
+              <a:t>Mở rộng cử chỉ: ngôn ngữ ký hiệu, số đếm 1–5</a:t>
+            </a:r>
+            <a:endParaRPr lang="en-US" sz="1250" dirty="0">
+              <a:solidFill>
+                <a:schemeClr val="tx1"/>
+              </a:solidFill>
+              <a:latin typeface="Times New Roman" panose="02020603050405020304" charset="0"/>
+              <a:ea typeface="Georgia" panose="02040502050405020303" pitchFamily="34" charset="-122"/>
+              <a:cs typeface="Times New Roman" panose="02020603050405020304" charset="0"/>
+            </a:endParaRPr>
           </a:p>
         </p:txBody>
       </p:sp>
@@ -3180,9 +3344,27 @@
                 <a:ea typeface="Georgia" panose="02040502050405020303" pitchFamily="34" charset="-122"/>
                 <a:cs typeface="Georgia" panose="02040502050405020303" pitchFamily="34" charset="-120"/>
               </a:rPr>
-              <a:t>→  Đa người dùng, nhiều điều kiện ánh sáng</a:t>
-            </a:r>
-            <a:endParaRPr lang="en-US" sz="1250" dirty="0"/>
+              <a:t>→  </a:t>
+            </a:r>
+            <a:r>
+              <a:rPr lang="en-US" sz="1250" dirty="0">
+                <a:solidFill>
+                  <a:schemeClr val="tx1"/>
+                </a:solidFill>
+                <a:latin typeface="Times New Roman" panose="02020603050405020304" charset="0"/>
+                <a:ea typeface="Georgia" panose="02040502050405020303" pitchFamily="34" charset="-122"/>
+                <a:cs typeface="Times New Roman" panose="02020603050405020304" charset="0"/>
+              </a:rPr>
+              <a:t>Đa người dùng, nhiều điều kiện ánh sáng</a:t>
+            </a:r>
+            <a:endParaRPr lang="en-US" sz="1250" dirty="0">
+              <a:solidFill>
+                <a:schemeClr val="tx1"/>
+              </a:solidFill>
+              <a:latin typeface="Times New Roman" panose="02020603050405020304" charset="0"/>
+              <a:ea typeface="Georgia" panose="02040502050405020303" pitchFamily="34" charset="-122"/>
+              <a:cs typeface="Times New Roman" panose="02020603050405020304" charset="0"/>
+            </a:endParaRPr>
           </a:p>
         </p:txBody>
       </p:sp>
@@ -3218,9 +3400,27 @@
                 <a:ea typeface="Georgia" panose="02040502050405020303" pitchFamily="34" charset="-122"/>
                 <a:cs typeface="Georgia" panose="02040502050405020303" pitchFamily="34" charset="-120"/>
               </a:rPr>
-              <a:t>→  Triển khai lên Arduino Nano 33 BLE Sense / Raspberry Pi</a:t>
-            </a:r>
-            <a:endParaRPr lang="en-US" sz="1250" dirty="0"/>
+              <a:t>→  </a:t>
+            </a:r>
+            <a:r>
+              <a:rPr lang="en-US" sz="1250" dirty="0">
+                <a:solidFill>
+                  <a:schemeClr val="tx1"/>
+                </a:solidFill>
+                <a:latin typeface="Times New Roman" panose="02020603050405020304" charset="0"/>
+                <a:ea typeface="Georgia" panose="02040502050405020303" pitchFamily="34" charset="-122"/>
+                <a:cs typeface="Times New Roman" panose="02020603050405020304" charset="0"/>
+              </a:rPr>
+              <a:t>Triển khai lên Arduino Nano 33 BLE Sense / Raspberry Pi</a:t>
+            </a:r>
+            <a:endParaRPr lang="en-US" sz="1250" dirty="0">
+              <a:solidFill>
+                <a:schemeClr val="tx1"/>
+              </a:solidFill>
+              <a:latin typeface="Times New Roman" panose="02020603050405020304" charset="0"/>
+              <a:ea typeface="Georgia" panose="02040502050405020303" pitchFamily="34" charset="-122"/>
+              <a:cs typeface="Times New Roman" panose="02020603050405020304" charset="0"/>
+            </a:endParaRPr>
           </a:p>
         </p:txBody>
       </p:sp>
@@ -3319,6 +3519,10 @@
             <a:prstDash val="solid"/>
           </a:ln>
         </p:spPr>
+        <p:txBody>
+          <a:bodyPr/>
+          <a:p/>
+        </p:txBody>
       </p:sp>
       <p:sp>
         <p:nvSpPr>
@@ -3351,13 +3555,16 @@
                 <a:solidFill>
                   <a:srgbClr val="FFFFFF"/>
                 </a:solidFill>
-                <a:latin typeface="Georgia" panose="02040502050405020303" pitchFamily="34" charset="0"/>
-                <a:ea typeface="Georgia" panose="02040502050405020303" pitchFamily="34" charset="-122"/>
-                <a:cs typeface="Georgia" panose="02040502050405020303" pitchFamily="34" charset="-120"/>
+                <a:latin typeface="Times New Roman" panose="02020603050405020304" charset="0"/>
+                <a:ea typeface="Georgia" panose="02040502050405020303" pitchFamily="34" charset="-122"/>
+                <a:cs typeface="Times New Roman" panose="02020603050405020304" charset="0"/>
               </a:rPr>
               <a:t>Tài liệu</a:t>
             </a:r>
-            <a:endParaRPr lang="en-US" sz="4400" dirty="0"/>
+            <a:endParaRPr lang="en-US" sz="4400" dirty="0">
+              <a:latin typeface="Times New Roman" panose="02020603050405020304" charset="0"/>
+              <a:cs typeface="Times New Roman" panose="02020603050405020304" charset="0"/>
+            </a:endParaRPr>
           </a:p>
           <a:p>
             <a:pPr marL="0" indent="0">
@@ -3371,13 +3578,16 @@
                 <a:solidFill>
                   <a:srgbClr val="FFFFFF"/>
                 </a:solidFill>
-                <a:latin typeface="Georgia" panose="02040502050405020303" pitchFamily="34" charset="0"/>
-                <a:ea typeface="Georgia" panose="02040502050405020303" pitchFamily="34" charset="-122"/>
-                <a:cs typeface="Georgia" panose="02040502050405020303" pitchFamily="34" charset="-120"/>
+                <a:latin typeface="Times New Roman" panose="02020603050405020304" charset="0"/>
+                <a:ea typeface="Georgia" panose="02040502050405020303" pitchFamily="34" charset="-122"/>
+                <a:cs typeface="Times New Roman" panose="02020603050405020304" charset="0"/>
               </a:rPr>
               <a:t>tham khảo</a:t>
             </a:r>
-            <a:endParaRPr lang="en-US" sz="4400" dirty="0"/>
+            <a:endParaRPr lang="en-US" sz="4400" dirty="0">
+              <a:latin typeface="Times New Roman" panose="02020603050405020304" charset="0"/>
+              <a:cs typeface="Times New Roman" panose="02020603050405020304" charset="0"/>
+            </a:endParaRPr>
           </a:p>
         </p:txBody>
       </p:sp>
@@ -3443,6 +3653,10 @@
             <a:prstDash val="solid"/>
           </a:ln>
         </p:spPr>
+        <p:txBody>
+          <a:bodyPr/>
+          <a:p/>
+        </p:txBody>
       </p:sp>
       <p:sp>
         <p:nvSpPr>
@@ -3506,6 +3720,10 @@
             <a:prstDash val="solid"/>
           </a:ln>
         </p:spPr>
+        <p:txBody>
+          <a:bodyPr/>
+          <a:p/>
+        </p:txBody>
       </p:sp>
       <p:sp>
         <p:nvSpPr>
@@ -3569,6 +3787,10 @@
             <a:prstDash val="solid"/>
           </a:ln>
         </p:spPr>
+        <p:txBody>
+          <a:bodyPr/>
+          <a:p/>
+        </p:txBody>
       </p:sp>
       <p:sp>
         <p:nvSpPr>
@@ -3632,6 +3854,10 @@
             <a:prstDash val="solid"/>
           </a:ln>
         </p:spPr>
+        <p:txBody>
+          <a:bodyPr/>
+          <a:p/>
+        </p:txBody>
       </p:sp>
       <p:sp>
         <p:nvSpPr>
@@ -3695,6 +3921,10 @@
             <a:prstDash val="solid"/>
           </a:ln>
         </p:spPr>
+        <p:txBody>
+          <a:bodyPr/>
+          <a:p/>
+        </p:txBody>
       </p:sp>
     </p:spTree>
   </p:cSld>
@@ -3753,6 +3983,10 @@
             <a:prstDash val="solid"/>
           </a:ln>
         </p:spPr>
+        <p:txBody>
+          <a:bodyPr/>
+          <a:p/>
+        </p:txBody>
       </p:sp>
       <p:sp>
         <p:nvSpPr>
@@ -3831,7 +4065,7 @@
                 <a:ea typeface="Georgia" panose="02040502050405020303" pitchFamily="34" charset="-122"/>
                 <a:cs typeface="Georgia" panose="02040502050405020303" pitchFamily="34" charset="-120"/>
               </a:rPr>
-              <a:t> nghe!</a:t>
+              <a:t>!</a:t>
             </a:r>
             <a:endParaRPr lang="en-US" sz="5200" dirty="0"/>
           </a:p>
@@ -3861,6 +4095,10 @@
             <a:prstDash val="solid"/>
           </a:ln>
         </p:spPr>
+        <p:txBody>
+          <a:bodyPr/>
+          <a:p/>
+        </p:txBody>
       </p:sp>
       <p:sp>
         <p:nvSpPr>
@@ -3890,9 +4128,9 @@
                 <a:solidFill>
                   <a:srgbClr val="111111"/>
                 </a:solidFill>
-                <a:latin typeface="+mn-ea"/>
-                <a:ea typeface="Georgia" panose="02040502050405020303" pitchFamily="34" charset="-122"/>
-                <a:cs typeface="+mn-ea"/>
+                <a:latin typeface="Times New Roman" panose="02020603050405020304" charset="0"/>
+                <a:ea typeface="Georgia" panose="02040502050405020303" pitchFamily="34" charset="-122"/>
+                <a:cs typeface="Times New Roman" panose="02020603050405020304" charset="0"/>
               </a:rPr>
               <a:t>Phạm An Dũng  |  N23DCCI018  |  D23CQCI01-N</a:t>
             </a:r>
@@ -3900,9 +4138,9 @@
               <a:solidFill>
                 <a:srgbClr val="111111"/>
               </a:solidFill>
-              <a:latin typeface="+mn-ea"/>
+              <a:latin typeface="Times New Roman" panose="02020603050405020304" charset="0"/>
               <a:ea typeface="Georgia" panose="02040502050405020303" pitchFamily="34" charset="-122"/>
-              <a:cs typeface="+mn-ea"/>
+              <a:cs typeface="Times New Roman" panose="02020603050405020304" charset="0"/>
             </a:endParaRPr>
           </a:p>
         </p:txBody>
@@ -3935,13 +4173,53 @@
                 <a:solidFill>
                   <a:srgbClr val="888888"/>
                 </a:solidFill>
-                <a:latin typeface="Georgia" panose="02040502050405020303" pitchFamily="34" charset="0"/>
-                <a:ea typeface="Georgia" panose="02040502050405020303" pitchFamily="34" charset="-122"/>
-                <a:cs typeface="Georgia" panose="02040502050405020303" pitchFamily="34" charset="-120"/>
-              </a:rPr>
-              <a:t>GVHD: Hồ Nhựt Minh  |  Mạng Cảm Biến – HK2 2024–2025</a:t>
-            </a:r>
-            <a:endParaRPr lang="en-US" sz="1200" dirty="0"/>
+                <a:latin typeface="Times New Roman" panose="02020603050405020304" charset="0"/>
+                <a:ea typeface="Georgia" panose="02040502050405020303" pitchFamily="34" charset="-122"/>
+                <a:cs typeface="Times New Roman" panose="02020603050405020304" charset="0"/>
+              </a:rPr>
+              <a:t>GVHD: Hồ Nhựt Minh  |  Mạng Cảm Biến – HK2 202</a:t>
+            </a:r>
+            <a:r>
+              <a:rPr lang="vi-VN" altLang="en-US" sz="1200" dirty="0">
+                <a:solidFill>
+                  <a:srgbClr val="888888"/>
+                </a:solidFill>
+                <a:latin typeface="Times New Roman" panose="02020603050405020304" charset="0"/>
+                <a:ea typeface="Georgia" panose="02040502050405020303" pitchFamily="34" charset="-122"/>
+                <a:cs typeface="Times New Roman" panose="02020603050405020304" charset="0"/>
+              </a:rPr>
+              <a:t>5</a:t>
+            </a:r>
+            <a:r>
+              <a:rPr lang="en-US" sz="1200" dirty="0">
+                <a:solidFill>
+                  <a:srgbClr val="888888"/>
+                </a:solidFill>
+                <a:latin typeface="Times New Roman" panose="02020603050405020304" charset="0"/>
+                <a:ea typeface="Georgia" panose="02040502050405020303" pitchFamily="34" charset="-122"/>
+                <a:cs typeface="Times New Roman" panose="02020603050405020304" charset="0"/>
+              </a:rPr>
+              <a:t>–202</a:t>
+            </a:r>
+            <a:r>
+              <a:rPr lang="vi-VN" altLang="en-US" sz="1200" dirty="0">
+                <a:solidFill>
+                  <a:srgbClr val="888888"/>
+                </a:solidFill>
+                <a:latin typeface="Times New Roman" panose="02020603050405020304" charset="0"/>
+                <a:ea typeface="Georgia" panose="02040502050405020303" pitchFamily="34" charset="-122"/>
+                <a:cs typeface="Times New Roman" panose="02020603050405020304" charset="0"/>
+              </a:rPr>
+              <a:t>6</a:t>
+            </a:r>
+            <a:endParaRPr lang="vi-VN" altLang="en-US" sz="1200" dirty="0">
+              <a:solidFill>
+                <a:srgbClr val="888888"/>
+              </a:solidFill>
+              <a:latin typeface="Times New Roman" panose="02020603050405020304" charset="0"/>
+              <a:ea typeface="Georgia" panose="02040502050405020303" pitchFamily="34" charset="-122"/>
+              <a:cs typeface="Times New Roman" panose="02020603050405020304" charset="0"/>
+            </a:endParaRPr>
           </a:p>
         </p:txBody>
       </p:sp>
@@ -3965,21 +4243,17 @@
           <a:bodyPr wrap="square" lIns="0" tIns="0" rIns="0" bIns="0" rtlCol="0" anchor="ctr"/>
           <a:lstStyle/>
           <a:p>
-            <a:pPr marL="0" indent="0">
-              <a:buNone/>
-            </a:pPr>
-            <a:r>
-              <a:rPr lang="en-US" sz="1100" dirty="0">
-                <a:solidFill>
-                  <a:srgbClr val="888888"/>
-                </a:solidFill>
-                <a:latin typeface="Georgia" panose="02040502050405020303" pitchFamily="34" charset="0"/>
-                <a:ea typeface="Georgia" panose="02040502050405020303" pitchFamily="34" charset="-122"/>
-                <a:cs typeface="Georgia" panose="02040502050405020303" pitchFamily="34" charset="-120"/>
+            <a:r>
+              <a:rPr lang="en-US" altLang="en-US">
+                <a:latin typeface="Times New Roman" panose="02020603050405020304" charset="0"/>
+                <a:cs typeface="Times New Roman" panose="02020603050405020304" charset="0"/>
               </a:rPr>
               <a:t>https://studio.edgeimpulse.com/studio/1013348</a:t>
             </a:r>
-            <a:endParaRPr lang="en-US" sz="1100" dirty="0"/>
+            <a:endParaRPr lang="en-US" altLang="en-US">
+              <a:latin typeface="Times New Roman" panose="02020603050405020304" charset="0"/>
+              <a:cs typeface="Times New Roman" panose="02020603050405020304" charset="0"/>
+            </a:endParaRPr>
           </a:p>
         </p:txBody>
       </p:sp>
@@ -4078,6 +4352,10 @@
             <a:prstDash val="solid"/>
           </a:ln>
         </p:spPr>
+        <p:txBody>
+          <a:bodyPr/>
+          <a:p/>
+        </p:txBody>
       </p:sp>
       <p:sp>
         <p:nvSpPr>
@@ -4429,13 +4707,20 @@
                 <a:solidFill>
                   <a:srgbClr val="111111"/>
                 </a:solidFill>
-                <a:latin typeface="Georgia" panose="02040502050405020303" pitchFamily="34" charset="0"/>
-                <a:ea typeface="Georgia" panose="02040502050405020303" pitchFamily="34" charset="-122"/>
-                <a:cs typeface="Georgia" panose="02040502050405020303" pitchFamily="34" charset="-120"/>
+                <a:latin typeface="Times New Roman" panose="02020603050405020304" charset="0"/>
+                <a:ea typeface="Georgia" panose="02040502050405020303" pitchFamily="34" charset="-122"/>
+                <a:cs typeface="Times New Roman" panose="02020603050405020304" charset="0"/>
               </a:rPr>
               <a:t>03</a:t>
             </a:r>
-            <a:endParaRPr lang="en-US" sz="1100" dirty="0"/>
+            <a:endParaRPr lang="en-US" sz="1100" dirty="0">
+              <a:solidFill>
+                <a:srgbClr val="111111"/>
+              </a:solidFill>
+              <a:latin typeface="Times New Roman" panose="02020603050405020304" charset="0"/>
+              <a:ea typeface="Georgia" panose="02040502050405020303" pitchFamily="34" charset="-122"/>
+              <a:cs typeface="Times New Roman" panose="02020603050405020304" charset="0"/>
+            </a:endParaRPr>
           </a:p>
         </p:txBody>
       </p:sp>
@@ -4463,6 +4748,10 @@
             <a:prstDash val="solid"/>
           </a:ln>
         </p:spPr>
+        <p:txBody>
+          <a:bodyPr/>
+          <a:p/>
+        </p:txBody>
       </p:sp>
       <p:sp>
         <p:nvSpPr>
@@ -4488,6 +4777,10 @@
             <a:prstDash val="solid"/>
           </a:ln>
         </p:spPr>
+        <p:txBody>
+          <a:bodyPr/>
+          <a:p/>
+        </p:txBody>
       </p:sp>
       <p:sp>
         <p:nvSpPr>
@@ -4520,13 +4813,16 @@
                 <a:solidFill>
                   <a:srgbClr val="111111"/>
                 </a:solidFill>
-                <a:latin typeface="Georgia" panose="02040502050405020303" pitchFamily="34" charset="0"/>
-                <a:ea typeface="Georgia" panose="02040502050405020303" pitchFamily="34" charset="-122"/>
-                <a:cs typeface="Georgia" panose="02040502050405020303" pitchFamily="34" charset="-120"/>
+                <a:latin typeface="Times New Roman" panose="02020603050405020304" charset="0"/>
+                <a:ea typeface="Georgia" panose="02040502050405020303" pitchFamily="34" charset="-122"/>
+                <a:cs typeface="Times New Roman" panose="02020603050405020304" charset="0"/>
               </a:rPr>
               <a:t>Tổng</a:t>
             </a:r>
-            <a:endParaRPr lang="en-US" sz="4400" dirty="0"/>
+            <a:endParaRPr lang="en-US" sz="4400" dirty="0">
+              <a:latin typeface="Times New Roman" panose="02020603050405020304" charset="0"/>
+              <a:cs typeface="Times New Roman" panose="02020603050405020304" charset="0"/>
+            </a:endParaRPr>
           </a:p>
           <a:p>
             <a:pPr marL="0" indent="0">
@@ -4540,13 +4836,16 @@
                 <a:solidFill>
                   <a:srgbClr val="111111"/>
                 </a:solidFill>
-                <a:latin typeface="Georgia" panose="02040502050405020303" pitchFamily="34" charset="0"/>
-                <a:ea typeface="Georgia" panose="02040502050405020303" pitchFamily="34" charset="-122"/>
-                <a:cs typeface="Georgia" panose="02040502050405020303" pitchFamily="34" charset="-120"/>
+                <a:latin typeface="Times New Roman" panose="02020603050405020304" charset="0"/>
+                <a:ea typeface="Georgia" panose="02040502050405020303" pitchFamily="34" charset="-122"/>
+                <a:cs typeface="Times New Roman" panose="02020603050405020304" charset="0"/>
               </a:rPr>
               <a:t>quan</a:t>
             </a:r>
-            <a:endParaRPr lang="en-US" sz="4400" dirty="0"/>
+            <a:endParaRPr lang="en-US" sz="4400" dirty="0">
+              <a:latin typeface="Times New Roman" panose="02020603050405020304" charset="0"/>
+              <a:cs typeface="Times New Roman" panose="02020603050405020304" charset="0"/>
+            </a:endParaRPr>
           </a:p>
           <a:p>
             <a:pPr marL="0" indent="0">
@@ -4560,13 +4859,16 @@
                 <a:solidFill>
                   <a:srgbClr val="111111"/>
                 </a:solidFill>
-                <a:latin typeface="Georgia" panose="02040502050405020303" pitchFamily="34" charset="0"/>
-                <a:ea typeface="Georgia" panose="02040502050405020303" pitchFamily="34" charset="-122"/>
-                <a:cs typeface="Georgia" panose="02040502050405020303" pitchFamily="34" charset="-120"/>
+                <a:latin typeface="Times New Roman" panose="02020603050405020304" charset="0"/>
+                <a:ea typeface="Georgia" panose="02040502050405020303" pitchFamily="34" charset="-122"/>
+                <a:cs typeface="Times New Roman" panose="02020603050405020304" charset="0"/>
               </a:rPr>
               <a:t>đề tài</a:t>
             </a:r>
-            <a:endParaRPr lang="en-US" sz="4400" dirty="0"/>
+            <a:endParaRPr lang="en-US" sz="4400" dirty="0">
+              <a:latin typeface="Times New Roman" panose="02020603050405020304" charset="0"/>
+              <a:cs typeface="Times New Roman" panose="02020603050405020304" charset="0"/>
+            </a:endParaRPr>
           </a:p>
         </p:txBody>
       </p:sp>
@@ -4598,10 +4900,18 @@
                 <a:solidFill>
                   <a:srgbClr val="000000"/>
                 </a:solidFill>
+                <a:latin typeface="Times New Roman" panose="02020603050405020304" charset="0"/>
+                <a:cs typeface="Times New Roman" panose="02020603050405020304" charset="0"/>
               </a:rPr>
               <a:t>🤚</a:t>
             </a:r>
-            <a:endParaRPr lang="en-US" sz="2000" dirty="0"/>
+            <a:endParaRPr lang="en-US" sz="2000" dirty="0">
+              <a:solidFill>
+                <a:srgbClr val="000000"/>
+              </a:solidFill>
+              <a:latin typeface="Times New Roman" panose="02020603050405020304" charset="0"/>
+              <a:cs typeface="Times New Roman" panose="02020603050405020304" charset="0"/>
+            </a:endParaRPr>
           </a:p>
         </p:txBody>
       </p:sp>
@@ -4633,13 +4943,20 @@
                 <a:solidFill>
                   <a:srgbClr val="111111"/>
                 </a:solidFill>
-                <a:latin typeface="Georgia" panose="02040502050405020303" pitchFamily="34" charset="0"/>
-                <a:ea typeface="Georgia" panose="02040502050405020303" pitchFamily="34" charset="-122"/>
-                <a:cs typeface="Georgia" panose="02040502050405020303" pitchFamily="34" charset="-120"/>
+                <a:latin typeface="Times New Roman" panose="02020603050405020304" charset="0"/>
+                <a:ea typeface="Georgia" panose="02040502050405020303" pitchFamily="34" charset="-122"/>
+                <a:cs typeface="Times New Roman" panose="02020603050405020304" charset="0"/>
               </a:rPr>
               <a:t>Xin chào</a:t>
             </a:r>
-            <a:endParaRPr lang="en-US" sz="1400" dirty="0"/>
+            <a:endParaRPr lang="en-US" sz="1400" b="1" dirty="0">
+              <a:solidFill>
+                <a:srgbClr val="111111"/>
+              </a:solidFill>
+              <a:latin typeface="Times New Roman" panose="02020603050405020304" charset="0"/>
+              <a:ea typeface="Georgia" panose="02040502050405020303" pitchFamily="34" charset="-122"/>
+              <a:cs typeface="Times New Roman" panose="02020603050405020304" charset="0"/>
+            </a:endParaRPr>
           </a:p>
         </p:txBody>
       </p:sp>
@@ -4671,13 +4988,20 @@
                 <a:solidFill>
                   <a:srgbClr val="888888"/>
                 </a:solidFill>
-                <a:latin typeface="Georgia" panose="02040502050405020303" pitchFamily="34" charset="0"/>
-                <a:ea typeface="Georgia" panose="02040502050405020303" pitchFamily="34" charset="-122"/>
-                <a:cs typeface="Georgia" panose="02040502050405020303" pitchFamily="34" charset="-120"/>
+                <a:latin typeface="Times New Roman" panose="02020603050405020304" charset="0"/>
+                <a:ea typeface="Georgia" panose="02040502050405020303" pitchFamily="34" charset="-122"/>
+                <a:cs typeface="Times New Roman" panose="02020603050405020304" charset="0"/>
               </a:rPr>
               <a:t>Vẫy tay chào</a:t>
             </a:r>
-            <a:endParaRPr lang="en-US" sz="1100" dirty="0"/>
+            <a:endParaRPr lang="en-US" sz="1100" dirty="0">
+              <a:solidFill>
+                <a:srgbClr val="888888"/>
+              </a:solidFill>
+              <a:latin typeface="Times New Roman" panose="02020603050405020304" charset="0"/>
+              <a:ea typeface="Georgia" panose="02040502050405020303" pitchFamily="34" charset="-122"/>
+              <a:cs typeface="Times New Roman" panose="02020603050405020304" charset="0"/>
+            </a:endParaRPr>
           </a:p>
         </p:txBody>
       </p:sp>
@@ -4709,13 +5033,20 @@
                 <a:solidFill>
                   <a:srgbClr val="111111"/>
                 </a:solidFill>
-                <a:latin typeface="Georgia" panose="02040502050405020303" pitchFamily="34" charset="0"/>
-                <a:ea typeface="Georgia" panose="02040502050405020303" pitchFamily="34" charset="-122"/>
-                <a:cs typeface="Georgia" panose="02040502050405020303" pitchFamily="34" charset="-120"/>
+                <a:latin typeface="Times New Roman" panose="02020603050405020304" charset="0"/>
+                <a:ea typeface="Georgia" panose="02040502050405020303" pitchFamily="34" charset="-122"/>
+                <a:cs typeface="Times New Roman" panose="02020603050405020304" charset="0"/>
               </a:rPr>
               <a:t>Tạm biệt</a:t>
             </a:r>
-            <a:endParaRPr lang="en-US" sz="1400" dirty="0"/>
+            <a:endParaRPr lang="en-US" sz="1400" b="1" dirty="0">
+              <a:solidFill>
+                <a:srgbClr val="111111"/>
+              </a:solidFill>
+              <a:latin typeface="Times New Roman" panose="02020603050405020304" charset="0"/>
+              <a:ea typeface="Georgia" panose="02040502050405020303" pitchFamily="34" charset="-122"/>
+              <a:cs typeface="Times New Roman" panose="02020603050405020304" charset="0"/>
+            </a:endParaRPr>
           </a:p>
         </p:txBody>
       </p:sp>
@@ -4747,13 +5078,20 @@
                 <a:solidFill>
                   <a:srgbClr val="888888"/>
                 </a:solidFill>
-                <a:latin typeface="Georgia" panose="02040502050405020303" pitchFamily="34" charset="0"/>
-                <a:ea typeface="Georgia" panose="02040502050405020303" pitchFamily="34" charset="-122"/>
-                <a:cs typeface="Georgia" panose="02040502050405020303" pitchFamily="34" charset="-120"/>
+                <a:latin typeface="Times New Roman" panose="02020603050405020304" charset="0"/>
+                <a:ea typeface="Georgia" panose="02040502050405020303" pitchFamily="34" charset="-122"/>
+                <a:cs typeface="Times New Roman" panose="02020603050405020304" charset="0"/>
               </a:rPr>
               <a:t>Vẫy tay từ biệt</a:t>
             </a:r>
-            <a:endParaRPr lang="en-US" sz="1100" dirty="0"/>
+            <a:endParaRPr lang="en-US" sz="1100" dirty="0">
+              <a:solidFill>
+                <a:srgbClr val="888888"/>
+              </a:solidFill>
+              <a:latin typeface="Times New Roman" panose="02020603050405020304" charset="0"/>
+              <a:ea typeface="Georgia" panose="02040502050405020303" pitchFamily="34" charset="-122"/>
+              <a:cs typeface="Times New Roman" panose="02020603050405020304" charset="0"/>
+            </a:endParaRPr>
           </a:p>
         </p:txBody>
       </p:sp>
@@ -4785,10 +5123,18 @@
                 <a:solidFill>
                   <a:srgbClr val="000000"/>
                 </a:solidFill>
+                <a:latin typeface="Times New Roman" panose="02020603050405020304" charset="0"/>
+                <a:cs typeface="Times New Roman" panose="02020603050405020304" charset="0"/>
               </a:rPr>
               <a:t>👌</a:t>
             </a:r>
-            <a:endParaRPr lang="en-US" sz="2000" dirty="0"/>
+            <a:endParaRPr lang="en-US" sz="2000" dirty="0">
+              <a:solidFill>
+                <a:srgbClr val="000000"/>
+              </a:solidFill>
+              <a:latin typeface="Times New Roman" panose="02020603050405020304" charset="0"/>
+              <a:cs typeface="Times New Roman" panose="02020603050405020304" charset="0"/>
+            </a:endParaRPr>
           </a:p>
         </p:txBody>
       </p:sp>
@@ -4820,13 +5166,20 @@
                 <a:solidFill>
                   <a:srgbClr val="111111"/>
                 </a:solidFill>
-                <a:latin typeface="Georgia" panose="02040502050405020303" pitchFamily="34" charset="0"/>
-                <a:ea typeface="Georgia" panose="02040502050405020303" pitchFamily="34" charset="-122"/>
-                <a:cs typeface="Georgia" panose="02040502050405020303" pitchFamily="34" charset="-120"/>
+                <a:latin typeface="Times New Roman" panose="02020603050405020304" charset="0"/>
+                <a:ea typeface="Georgia" panose="02040502050405020303" pitchFamily="34" charset="-122"/>
+                <a:cs typeface="Times New Roman" panose="02020603050405020304" charset="0"/>
               </a:rPr>
               <a:t>OK</a:t>
             </a:r>
-            <a:endParaRPr lang="en-US" sz="1400" dirty="0"/>
+            <a:endParaRPr lang="en-US" sz="1400" b="1" dirty="0">
+              <a:solidFill>
+                <a:srgbClr val="111111"/>
+              </a:solidFill>
+              <a:latin typeface="Times New Roman" panose="02020603050405020304" charset="0"/>
+              <a:ea typeface="Georgia" panose="02040502050405020303" pitchFamily="34" charset="-122"/>
+              <a:cs typeface="Times New Roman" panose="02020603050405020304" charset="0"/>
+            </a:endParaRPr>
           </a:p>
         </p:txBody>
       </p:sp>
@@ -4858,13 +5211,20 @@
                 <a:solidFill>
                   <a:srgbClr val="888888"/>
                 </a:solidFill>
-                <a:latin typeface="Georgia" panose="02040502050405020303" pitchFamily="34" charset="0"/>
-                <a:ea typeface="Georgia" panose="02040502050405020303" pitchFamily="34" charset="-122"/>
-                <a:cs typeface="Georgia" panose="02040502050405020303" pitchFamily="34" charset="-120"/>
+                <a:latin typeface="Times New Roman" panose="02020603050405020304" charset="0"/>
+                <a:ea typeface="Georgia" panose="02040502050405020303" pitchFamily="34" charset="-122"/>
+                <a:cs typeface="Times New Roman" panose="02020603050405020304" charset="0"/>
               </a:rPr>
               <a:t>Ngón cái + ngón trỏ</a:t>
             </a:r>
-            <a:endParaRPr lang="en-US" sz="1100" dirty="0"/>
+            <a:endParaRPr lang="en-US" sz="1100" dirty="0">
+              <a:solidFill>
+                <a:srgbClr val="888888"/>
+              </a:solidFill>
+              <a:latin typeface="Times New Roman" panose="02020603050405020304" charset="0"/>
+              <a:ea typeface="Georgia" panose="02040502050405020303" pitchFamily="34" charset="-122"/>
+              <a:cs typeface="Times New Roman" panose="02020603050405020304" charset="0"/>
+            </a:endParaRPr>
           </a:p>
         </p:txBody>
       </p:sp>
@@ -4896,10 +5256,18 @@
                 <a:solidFill>
                   <a:srgbClr val="000000"/>
                 </a:solidFill>
+                <a:latin typeface="Times New Roman" panose="02020603050405020304" charset="0"/>
+                <a:cs typeface="Times New Roman" panose="02020603050405020304" charset="0"/>
               </a:rPr>
               <a:t>️</a:t>
             </a:r>
-            <a:endParaRPr lang="en-US" sz="2000" dirty="0"/>
+            <a:endParaRPr lang="en-US" sz="2000" dirty="0">
+              <a:solidFill>
+                <a:srgbClr val="000000"/>
+              </a:solidFill>
+              <a:latin typeface="Times New Roman" panose="02020603050405020304" charset="0"/>
+              <a:cs typeface="Times New Roman" panose="02020603050405020304" charset="0"/>
+            </a:endParaRPr>
           </a:p>
         </p:txBody>
       </p:sp>
@@ -4931,13 +5299,20 @@
                 <a:solidFill>
                   <a:srgbClr val="111111"/>
                 </a:solidFill>
-                <a:latin typeface="Georgia" panose="02040502050405020303" pitchFamily="34" charset="0"/>
-                <a:ea typeface="Georgia" panose="02040502050405020303" pitchFamily="34" charset="-122"/>
-                <a:cs typeface="Georgia" panose="02040502050405020303" pitchFamily="34" charset="-120"/>
+                <a:latin typeface="Times New Roman" panose="02020603050405020304" charset="0"/>
+                <a:ea typeface="Georgia" panose="02040502050405020303" pitchFamily="34" charset="-122"/>
+                <a:cs typeface="Times New Roman" panose="02020603050405020304" charset="0"/>
               </a:rPr>
               <a:t>Không</a:t>
             </a:r>
-            <a:endParaRPr lang="en-US" sz="1400" dirty="0"/>
+            <a:endParaRPr lang="en-US" sz="1400" b="1" dirty="0">
+              <a:solidFill>
+                <a:srgbClr val="111111"/>
+              </a:solidFill>
+              <a:latin typeface="Times New Roman" panose="02020603050405020304" charset="0"/>
+              <a:ea typeface="Georgia" panose="02040502050405020303" pitchFamily="34" charset="-122"/>
+              <a:cs typeface="Times New Roman" panose="02020603050405020304" charset="0"/>
+            </a:endParaRPr>
           </a:p>
         </p:txBody>
       </p:sp>
@@ -4969,13 +5344,20 @@
                 <a:solidFill>
                   <a:srgbClr val="888888"/>
                 </a:solidFill>
-                <a:latin typeface="Georgia" panose="02040502050405020303" pitchFamily="34" charset="0"/>
-                <a:ea typeface="Georgia" panose="02040502050405020303" pitchFamily="34" charset="-122"/>
-                <a:cs typeface="Georgia" panose="02040502050405020303" pitchFamily="34" charset="-120"/>
+                <a:latin typeface="Times New Roman" panose="02020603050405020304" charset="0"/>
+                <a:ea typeface="Georgia" panose="02040502050405020303" pitchFamily="34" charset="-122"/>
+                <a:cs typeface="Times New Roman" panose="02020603050405020304" charset="0"/>
               </a:rPr>
               <a:t>Lắc / xoay bàn tay</a:t>
             </a:r>
-            <a:endParaRPr lang="en-US" sz="1100" dirty="0"/>
+            <a:endParaRPr lang="en-US" sz="1100" dirty="0">
+              <a:solidFill>
+                <a:srgbClr val="888888"/>
+              </a:solidFill>
+              <a:latin typeface="Times New Roman" panose="02020603050405020304" charset="0"/>
+              <a:ea typeface="Georgia" panose="02040502050405020303" pitchFamily="34" charset="-122"/>
+              <a:cs typeface="Times New Roman" panose="02020603050405020304" charset="0"/>
+            </a:endParaRPr>
           </a:p>
         </p:txBody>
       </p:sp>
@@ -5082,6 +5464,15 @@
             <a:prstDash val="solid"/>
           </a:ln>
         </p:spPr>
+        <p:txBody>
+          <a:bodyPr/>
+          <a:p>
+            <a:endParaRPr>
+              <a:latin typeface="Times New Roman" panose="02020603050405020304" charset="0"/>
+              <a:cs typeface="Times New Roman" panose="02020603050405020304" charset="0"/>
+            </a:endParaRPr>
+          </a:p>
+        </p:txBody>
       </p:sp>
       <p:sp>
         <p:nvSpPr>
@@ -5148,6 +5539,15 @@
             <a:prstDash val="solid"/>
           </a:ln>
         </p:spPr>
+        <p:txBody>
+          <a:bodyPr/>
+          <a:p>
+            <a:endParaRPr>
+              <a:latin typeface="Times New Roman" panose="02020603050405020304" charset="0"/>
+              <a:cs typeface="Times New Roman" panose="02020603050405020304" charset="0"/>
+            </a:endParaRPr>
+          </a:p>
+        </p:txBody>
       </p:sp>
       <p:sp>
         <p:nvSpPr>
@@ -5214,6 +5614,15 @@
             <a:prstDash val="solid"/>
           </a:ln>
         </p:spPr>
+        <p:txBody>
+          <a:bodyPr/>
+          <a:p>
+            <a:endParaRPr>
+              <a:latin typeface="Times New Roman" panose="02020603050405020304" charset="0"/>
+              <a:cs typeface="Times New Roman" panose="02020603050405020304" charset="0"/>
+            </a:endParaRPr>
+          </a:p>
+        </p:txBody>
       </p:sp>
       <p:sp>
         <p:nvSpPr>
@@ -5399,6 +5808,10 @@
             <a:prstDash val="solid"/>
           </a:ln>
         </p:spPr>
+        <p:txBody>
+          <a:bodyPr/>
+          <a:p/>
+        </p:txBody>
       </p:sp>
       <p:sp>
         <p:nvSpPr>
@@ -5519,21 +5932,23 @@
           <a:bodyPr wrap="square" lIns="0" tIns="0" rIns="0" bIns="0" rtlCol="0" anchor="ctr"/>
           <a:lstStyle/>
           <a:p>
-            <a:pPr marL="0" indent="0">
-              <a:buNone/>
-            </a:pPr>
-            <a:r>
-              <a:rPr lang="en-US" sz="1600" dirty="0">
-                <a:solidFill>
-                  <a:srgbClr val="FFFFFF"/>
-                </a:solidFill>
-                <a:latin typeface="Georgia" panose="02040502050405020303" pitchFamily="34" charset="0"/>
-                <a:ea typeface="Georgia" panose="02040502050405020303" pitchFamily="34" charset="-122"/>
-                <a:cs typeface="Georgia" panose="02040502050405020303" pitchFamily="34" charset="-120"/>
-              </a:rPr>
-              <a:t>Xây dựng mô hình nhận diện 4 cử chỉ tay với F1 ≥ 0.85</a:t>
-            </a:r>
-            <a:endParaRPr lang="en-US" sz="1600" dirty="0"/>
+            <a:r>
+              <a:rPr>
+                <a:solidFill>
+                  <a:schemeClr val="bg1"/>
+                </a:solidFill>
+                <a:latin typeface="Times New Roman" panose="02020603050405020304" charset="0"/>
+                <a:cs typeface="Times New Roman" panose="02020603050405020304" charset="0"/>
+              </a:rPr>
+              <a:t>Xây dựng mô hình nhận diện 4 cử chỉ tay: Xin chào, Tạm biệt, OK và Không</a:t>
+            </a:r>
+            <a:endParaRPr>
+              <a:solidFill>
+                <a:schemeClr val="bg1"/>
+              </a:solidFill>
+              <a:latin typeface="Times New Roman" panose="02020603050405020304" charset="0"/>
+              <a:cs typeface="Times New Roman" panose="02020603050405020304" charset="0"/>
+            </a:endParaRPr>
           </a:p>
         </p:txBody>
       </p:sp>
@@ -5561,6 +5976,10 @@
             <a:prstDash val="solid"/>
           </a:ln>
         </p:spPr>
+        <p:txBody>
+          <a:bodyPr/>
+          <a:p/>
+        </p:txBody>
       </p:sp>
       <p:sp>
         <p:nvSpPr>
@@ -5662,6 +6081,10 @@
             <a:prstDash val="solid"/>
           </a:ln>
         </p:spPr>
+        <p:txBody>
+          <a:bodyPr/>
+          <a:p/>
+        </p:txBody>
       </p:sp>
       <p:sp>
         <p:nvSpPr>
@@ -5763,6 +6186,10 @@
             <a:prstDash val="solid"/>
           </a:ln>
         </p:spPr>
+        <p:txBody>
+          <a:bodyPr/>
+          <a:p/>
+        </p:txBody>
       </p:sp>
       <p:sp>
         <p:nvSpPr>
@@ -5864,6 +6291,10 @@
             <a:prstDash val="solid"/>
           </a:ln>
         </p:spPr>
+        <p:txBody>
+          <a:bodyPr/>
+          <a:p/>
+        </p:txBody>
       </p:sp>
     </p:spTree>
   </p:cSld>
@@ -5960,6 +6391,10 @@
             <a:prstDash val="solid"/>
           </a:ln>
         </p:spPr>
+        <p:txBody>
+          <a:bodyPr/>
+          <a:p/>
+        </p:txBody>
       </p:sp>
       <p:sp>
         <p:nvSpPr>
@@ -6084,6 +6519,10 @@
             <a:prstDash val="solid"/>
           </a:ln>
         </p:spPr>
+        <p:txBody>
+          <a:bodyPr/>
+          <a:p/>
+        </p:txBody>
       </p:sp>
       <p:sp>
         <p:nvSpPr>
@@ -6112,9 +6551,9 @@
               <a:buNone/>
             </a:pPr>
             <a:r>
-              <a:rPr lang="en-US" sz="1100" dirty="0">
-                <a:solidFill>
-                  <a:srgbClr val="888888"/>
+              <a:rPr lang="en-US" sz="1400" dirty="0">
+                <a:solidFill>
+                  <a:schemeClr val="tx1"/>
                 </a:solidFill>
                 <a:latin typeface="Georgia" panose="02040502050405020303" pitchFamily="34" charset="0"/>
                 <a:ea typeface="Georgia" panose="02040502050405020303" pitchFamily="34" charset="-122"/>
@@ -6122,7 +6561,14 @@
               </a:rPr>
               <a:t>AI chạy trực tiếp trên vi điều khiển. RAM &lt; 1MB, không cần cloud. Giảm trễ và bảo vệ dữ liệu.</a:t>
             </a:r>
-            <a:endParaRPr lang="en-US" sz="1100" dirty="0"/>
+            <a:endParaRPr lang="en-US" sz="1400" dirty="0">
+              <a:solidFill>
+                <a:schemeClr val="tx1"/>
+              </a:solidFill>
+              <a:latin typeface="Georgia" panose="02040502050405020303" pitchFamily="34" charset="0"/>
+              <a:ea typeface="Georgia" panose="02040502050405020303" pitchFamily="34" charset="-122"/>
+              <a:cs typeface="Georgia" panose="02040502050405020303" pitchFamily="34" charset="-120"/>
+            </a:endParaRPr>
           </a:p>
         </p:txBody>
       </p:sp>
@@ -6188,6 +6634,10 @@
             <a:prstDash val="solid"/>
           </a:ln>
         </p:spPr>
+        <p:txBody>
+          <a:bodyPr/>
+          <a:p/>
+        </p:txBody>
       </p:sp>
       <p:sp>
         <p:nvSpPr>
@@ -6216,9 +6666,9 @@
               <a:buNone/>
             </a:pPr>
             <a:r>
-              <a:rPr lang="en-US" sz="1100" dirty="0">
-                <a:solidFill>
-                  <a:srgbClr val="888888"/>
+              <a:rPr lang="en-US" sz="1400" dirty="0">
+                <a:solidFill>
+                  <a:schemeClr val="tx1"/>
                 </a:solidFill>
                 <a:latin typeface="Georgia" panose="02040502050405020303" pitchFamily="34" charset="0"/>
                 <a:ea typeface="Georgia" panose="02040502050405020303" pitchFamily="34" charset="-122"/>
@@ -6226,7 +6676,14 @@
               </a:rPr>
               <a:t>Nền tảng ML nhúng end-to-end. Giao diện web: thu thập → train → deploy. Hỗ trợ Arduino, Cortex-M, WebAssembly.</a:t>
             </a:r>
-            <a:endParaRPr lang="en-US" sz="1100" dirty="0"/>
+            <a:endParaRPr lang="en-US" sz="1400" dirty="0">
+              <a:solidFill>
+                <a:schemeClr val="tx1"/>
+              </a:solidFill>
+              <a:latin typeface="Georgia" panose="02040502050405020303" pitchFamily="34" charset="0"/>
+              <a:ea typeface="Georgia" panose="02040502050405020303" pitchFamily="34" charset="-122"/>
+              <a:cs typeface="Georgia" panose="02040502050405020303" pitchFamily="34" charset="-120"/>
+            </a:endParaRPr>
           </a:p>
         </p:txBody>
       </p:sp>
@@ -6292,6 +6749,10 @@
             <a:prstDash val="solid"/>
           </a:ln>
         </p:spPr>
+        <p:txBody>
+          <a:bodyPr/>
+          <a:p/>
+        </p:txBody>
       </p:sp>
       <p:sp>
         <p:nvSpPr>
@@ -6320,17 +6781,24 @@
               <a:buNone/>
             </a:pPr>
             <a:r>
-              <a:rPr lang="en-US" sz="1100" dirty="0">
-                <a:solidFill>
-                  <a:srgbClr val="888888"/>
-                </a:solidFill>
-                <a:latin typeface="Georgia" panose="02040502050405020303" pitchFamily="34" charset="0"/>
-                <a:ea typeface="Georgia" panose="02040502050405020303" pitchFamily="34" charset="-122"/>
-                <a:cs typeface="Georgia" panose="02040502050405020303" pitchFamily="34" charset="-120"/>
+              <a:rPr lang="en-US" sz="1400" dirty="0">
+                <a:solidFill>
+                  <a:schemeClr val="tx1"/>
+                </a:solidFill>
+                <a:latin typeface="Times New Roman" panose="02020603050405020304" charset="0"/>
+                <a:ea typeface="Georgia" panose="02040502050405020303" pitchFamily="34" charset="-122"/>
+                <a:cs typeface="Times New Roman" panose="02020603050405020304" charset="0"/>
               </a:rPr>
               <a:t>CNN tối ưu cho thiết bị nhúng. 96×96px, hệ số 0.35. Dùng depthwise separable convolution.</a:t>
             </a:r>
-            <a:endParaRPr lang="en-US" sz="1100" dirty="0"/>
+            <a:endParaRPr lang="en-US" sz="1400" dirty="0">
+              <a:solidFill>
+                <a:schemeClr val="tx1"/>
+              </a:solidFill>
+              <a:latin typeface="Times New Roman" panose="02020603050405020304" charset="0"/>
+              <a:ea typeface="Georgia" panose="02040502050405020303" pitchFamily="34" charset="-122"/>
+              <a:cs typeface="Times New Roman" panose="02020603050405020304" charset="0"/>
+            </a:endParaRPr>
           </a:p>
         </p:txBody>
       </p:sp>
@@ -6396,6 +6864,10 @@
             <a:prstDash val="solid"/>
           </a:ln>
         </p:spPr>
+        <p:txBody>
+          <a:bodyPr/>
+          <a:p/>
+        </p:txBody>
       </p:sp>
       <p:sp>
         <p:nvSpPr>
@@ -6424,9 +6896,9 @@
               <a:buNone/>
             </a:pPr>
             <a:r>
-              <a:rPr lang="en-US" sz="1100" dirty="0">
-                <a:solidFill>
-                  <a:srgbClr val="888888"/>
+              <a:rPr lang="en-US" sz="1400" dirty="0">
+                <a:solidFill>
+                  <a:schemeClr val="tx1"/>
                 </a:solidFill>
                 <a:latin typeface="Georgia" panose="02040502050405020303" pitchFamily="34" charset="0"/>
                 <a:ea typeface="Georgia" panose="02040502050405020303" pitchFamily="34" charset="-122"/>
@@ -6434,7 +6906,14 @@
               </a:rPr>
               <a:t>Faster Objects, More Objects. Dự đoán theo lưới, không cần bounding box. Cortex-M4: 593ms, 228KB RAM.</a:t>
             </a:r>
-            <a:endParaRPr lang="en-US" sz="1100" dirty="0"/>
+            <a:endParaRPr lang="en-US" sz="1400" dirty="0">
+              <a:solidFill>
+                <a:schemeClr val="tx1"/>
+              </a:solidFill>
+              <a:latin typeface="Georgia" panose="02040502050405020303" pitchFamily="34" charset="0"/>
+              <a:ea typeface="Georgia" panose="02040502050405020303" pitchFamily="34" charset="-122"/>
+              <a:cs typeface="Georgia" panose="02040502050405020303" pitchFamily="34" charset="-120"/>
+            </a:endParaRPr>
           </a:p>
         </p:txBody>
       </p:sp>
@@ -6500,6 +6979,10 @@
             <a:prstDash val="solid"/>
           </a:ln>
         </p:spPr>
+        <p:txBody>
+          <a:bodyPr/>
+          <a:p/>
+        </p:txBody>
       </p:sp>
       <p:sp>
         <p:nvSpPr>
@@ -6528,6 +7011,17 @@
               <a:buNone/>
             </a:pPr>
             <a:r>
+              <a:rPr lang="en-US" sz="1400" dirty="0">
+                <a:solidFill>
+                  <a:schemeClr val="tx1"/>
+                </a:solidFill>
+                <a:latin typeface="Georgia" panose="02040502050405020303" pitchFamily="34" charset="0"/>
+                <a:ea typeface="Georgia" panose="02040502050405020303" pitchFamily="34" charset="-122"/>
+                <a:cs typeface="Georgia" panose="02040502050405020303" pitchFamily="34" charset="-120"/>
+              </a:rPr>
+              <a:t>Dùng trọng số pre-trained từ ImageNet. 60 epochs, LR = 0.001, data augmentation bật</a:t>
+            </a:r>
+            <a:r>
               <a:rPr lang="en-US" sz="1100" dirty="0">
                 <a:solidFill>
                   <a:srgbClr val="888888"/>
@@ -6536,7 +7030,7 @@
                 <a:ea typeface="Georgia" panose="02040502050405020303" pitchFamily="34" charset="-122"/>
                 <a:cs typeface="Georgia" panose="02040502050405020303" pitchFamily="34" charset="-120"/>
               </a:rPr>
-              <a:t>Dùng trọng số pre-trained từ ImageNet. 60 epochs, LR = 0.001, data augmentation bật.</a:t>
+              <a:t>.</a:t>
             </a:r>
             <a:endParaRPr lang="en-US" sz="1100" dirty="0"/>
           </a:p>
@@ -6604,6 +7098,10 @@
             <a:prstDash val="solid"/>
           </a:ln>
         </p:spPr>
+        <p:txBody>
+          <a:bodyPr/>
+          <a:p/>
+        </p:txBody>
       </p:sp>
       <p:sp>
         <p:nvSpPr>
@@ -6625,24 +7123,17 @@
           <a:bodyPr wrap="square" lIns="0" tIns="0" rIns="0" bIns="0" rtlCol="0" anchor="ctr"/>
           <a:lstStyle/>
           <a:p>
-            <a:pPr marL="0" indent="0">
-              <a:lnSpc>
-                <a:spcPct val="140000"/>
-              </a:lnSpc>
-              <a:buNone/>
-            </a:pPr>
-            <a:r>
-              <a:rPr lang="en-US" sz="1100" dirty="0">
-                <a:solidFill>
-                  <a:srgbClr val="888888"/>
-                </a:solidFill>
-                <a:latin typeface="Georgia" panose="02040502050405020303" pitchFamily="34" charset="0"/>
-                <a:ea typeface="Georgia" panose="02040502050405020303" pitchFamily="34" charset="-122"/>
-                <a:cs typeface="Georgia" panose="02040502050405020303" pitchFamily="34" charset="-120"/>
+            <a:r>
+              <a:rPr sz="1400">
+                <a:latin typeface="Times New Roman" panose="02020603050405020304" charset="0"/>
+                <a:cs typeface="Times New Roman" panose="02020603050405020304" charset="0"/>
               </a:rPr>
               <a:t>Accuracy, F1-score, Confusion matrix, ROC AUC, Precision, Recall. Yêu cầu: F1 ≥ 0.85.</a:t>
             </a:r>
-            <a:endParaRPr lang="en-US" sz="1100" dirty="0"/>
+            <a:endParaRPr sz="1400">
+              <a:latin typeface="Times New Roman" panose="02020603050405020304" charset="0"/>
+              <a:cs typeface="Times New Roman" panose="02020603050405020304" charset="0"/>
+            </a:endParaRPr>
           </a:p>
         </p:txBody>
       </p:sp>
@@ -6741,6 +7232,10 @@
             <a:prstDash val="solid"/>
           </a:ln>
         </p:spPr>
+        <p:txBody>
+          <a:bodyPr/>
+          <a:p/>
+        </p:txBody>
       </p:sp>
       <p:sp>
         <p:nvSpPr>
@@ -7473,6 +7968,10 @@
             <a:prstDash val="solid"/>
           </a:ln>
         </p:spPr>
+        <p:txBody>
+          <a:bodyPr/>
+          <a:p/>
+        </p:txBody>
       </p:sp>
       <p:sp>
         <p:nvSpPr>
@@ -7574,6 +8073,10 @@
             <a:prstDash val="solid"/>
           </a:ln>
         </p:spPr>
+        <p:txBody>
+          <a:bodyPr/>
+          <a:p/>
+        </p:txBody>
       </p:sp>
       <p:sp>
         <p:nvSpPr>
@@ -7675,6 +8178,10 @@
             <a:prstDash val="solid"/>
           </a:ln>
         </p:spPr>
+        <p:txBody>
+          <a:bodyPr/>
+          <a:p/>
+        </p:txBody>
       </p:sp>
       <p:sp>
         <p:nvSpPr>
@@ -7776,6 +8283,10 @@
             <a:prstDash val="solid"/>
           </a:ln>
         </p:spPr>
+        <p:txBody>
+          <a:bodyPr/>
+          <a:p/>
+        </p:txBody>
       </p:sp>
     </p:spTree>
   </p:cSld>
@@ -7872,6 +8383,10 @@
             <a:prstDash val="solid"/>
           </a:ln>
         </p:spPr>
+        <p:txBody>
+          <a:bodyPr/>
+          <a:p/>
+        </p:txBody>
       </p:sp>
       <p:sp>
         <p:nvSpPr>
@@ -7958,6 +8473,10 @@
             <a:prstDash val="solid"/>
           </a:ln>
         </p:spPr>
+        <p:txBody>
+          <a:bodyPr/>
+          <a:p/>
+        </p:txBody>
       </p:sp>
       <p:sp>
         <p:nvSpPr>
@@ -8076,6 +8595,10 @@
             <a:prstDash val="solid"/>
           </a:ln>
         </p:spPr>
+        <p:txBody>
+          <a:bodyPr/>
+          <a:p/>
+        </p:txBody>
       </p:sp>
       <p:sp>
         <p:nvSpPr>
@@ -8194,6 +8717,10 @@
             <a:prstDash val="solid"/>
           </a:ln>
         </p:spPr>
+        <p:txBody>
+          <a:bodyPr/>
+          <a:p/>
+        </p:txBody>
       </p:sp>
       <p:sp>
         <p:nvSpPr>
@@ -8312,6 +8839,10 @@
             <a:prstDash val="solid"/>
           </a:ln>
         </p:spPr>
+        <p:txBody>
+          <a:bodyPr/>
+          <a:p/>
+        </p:txBody>
       </p:sp>
       <p:sp>
         <p:nvSpPr>
@@ -8468,6 +8999,10 @@
             <a:prstDash val="solid"/>
           </a:ln>
         </p:spPr>
+        <p:txBody>
+          <a:bodyPr/>
+          <a:p/>
+        </p:txBody>
       </p:sp>
       <p:sp>
         <p:nvSpPr>
@@ -8569,6 +9104,10 @@
             <a:prstDash val="solid"/>
           </a:ln>
         </p:spPr>
+        <p:txBody>
+          <a:bodyPr/>
+          <a:p/>
+        </p:txBody>
       </p:sp>
       <p:sp>
         <p:nvSpPr>
@@ -8670,6 +9209,10 @@
             <a:prstDash val="solid"/>
           </a:ln>
         </p:spPr>
+        <p:txBody>
+          <a:bodyPr/>
+          <a:p/>
+        </p:txBody>
       </p:sp>
       <p:sp>
         <p:nvSpPr>
@@ -8771,6 +9314,10 @@
             <a:prstDash val="solid"/>
           </a:ln>
         </p:spPr>
+        <p:txBody>
+          <a:bodyPr/>
+          <a:p/>
+        </p:txBody>
       </p:sp>
     </p:spTree>
   </p:cSld>
@@ -8867,6 +9414,10 @@
             <a:prstDash val="solid"/>
           </a:ln>
         </p:spPr>
+        <p:txBody>
+          <a:bodyPr/>
+          <a:p/>
+        </p:txBody>
       </p:sp>
       <p:sp>
         <p:nvSpPr>
@@ -8876,8 +9427,8 @@
         </p:nvSpPr>
         <p:spPr>
           <a:xfrm>
-            <a:off x="411480" y="182880"/>
-            <a:ext cx="8321040" cy="1371600"/>
+            <a:off x="411480" y="201295"/>
+            <a:ext cx="3302000" cy="1371600"/>
           </a:xfrm>
           <a:prstGeom prst="rect">
             <a:avLst/>
@@ -8937,7 +9488,7 @@
         </p:nvSpPr>
         <p:spPr>
           <a:xfrm>
-            <a:off x="411480" y="1691640"/>
+            <a:off x="411480" y="1572895"/>
             <a:ext cx="1965960" cy="777240"/>
           </a:xfrm>
           <a:prstGeom prst="rect">
@@ -8975,7 +9526,7 @@
         </p:nvSpPr>
         <p:spPr>
           <a:xfrm>
-            <a:off x="685800" y="2487168"/>
+            <a:off x="631190" y="2341118"/>
             <a:ext cx="1417320" cy="9144"/>
           </a:xfrm>
           <a:prstGeom prst="rect">
@@ -8991,6 +9542,10 @@
             <a:prstDash val="solid"/>
           </a:ln>
         </p:spPr>
+        <p:txBody>
+          <a:bodyPr/>
+          <a:p/>
+        </p:txBody>
       </p:sp>
       <p:sp>
         <p:nvSpPr>
@@ -9000,7 +9555,7 @@
         </p:nvSpPr>
         <p:spPr>
           <a:xfrm>
-            <a:off x="411480" y="2542032"/>
+            <a:off x="411480" y="2350262"/>
             <a:ext cx="1965960" cy="274320"/>
           </a:xfrm>
           <a:prstGeom prst="rect">
@@ -9038,7 +9593,7 @@
         </p:nvSpPr>
         <p:spPr>
           <a:xfrm>
-            <a:off x="2587752" y="1691640"/>
+            <a:off x="411607" y="2423160"/>
             <a:ext cx="1965960" cy="777240"/>
           </a:xfrm>
           <a:prstGeom prst="rect">
@@ -9076,7 +9631,7 @@
         </p:nvSpPr>
         <p:spPr>
           <a:xfrm>
-            <a:off x="2862072" y="2487168"/>
+            <a:off x="631317" y="3058668"/>
             <a:ext cx="1417320" cy="9144"/>
           </a:xfrm>
           <a:prstGeom prst="rect">
@@ -9092,6 +9647,10 @@
             <a:prstDash val="solid"/>
           </a:ln>
         </p:spPr>
+        <p:txBody>
+          <a:bodyPr/>
+          <a:p/>
+        </p:txBody>
       </p:sp>
       <p:sp>
         <p:nvSpPr>
@@ -9101,7 +9660,7 @@
         </p:nvSpPr>
         <p:spPr>
           <a:xfrm>
-            <a:off x="2587752" y="2542032"/>
+            <a:off x="411607" y="3118612"/>
             <a:ext cx="1965960" cy="274320"/>
           </a:xfrm>
           <a:prstGeom prst="rect">
@@ -9139,7 +9698,7 @@
         </p:nvSpPr>
         <p:spPr>
           <a:xfrm>
-            <a:off x="4764024" y="1691640"/>
+            <a:off x="411734" y="3154045"/>
             <a:ext cx="1965960" cy="777240"/>
           </a:xfrm>
           <a:prstGeom prst="rect">
@@ -9177,7 +9736,7 @@
         </p:nvSpPr>
         <p:spPr>
           <a:xfrm>
-            <a:off x="5038344" y="2487168"/>
+            <a:off x="631444" y="3854323"/>
             <a:ext cx="1417320" cy="9144"/>
           </a:xfrm>
           <a:prstGeom prst="rect">
@@ -9193,6 +9752,10 @@
             <a:prstDash val="solid"/>
           </a:ln>
         </p:spPr>
+        <p:txBody>
+          <a:bodyPr/>
+          <a:p/>
+        </p:txBody>
       </p:sp>
       <p:sp>
         <p:nvSpPr>
@@ -9202,7 +9765,7 @@
         </p:nvSpPr>
         <p:spPr>
           <a:xfrm>
-            <a:off x="4764024" y="2542032"/>
+            <a:off x="411734" y="3886962"/>
             <a:ext cx="1965960" cy="274320"/>
           </a:xfrm>
           <a:prstGeom prst="rect">
@@ -9240,7 +9803,7 @@
         </p:nvSpPr>
         <p:spPr>
           <a:xfrm>
-            <a:off x="6940296" y="1691640"/>
+            <a:off x="411226" y="3886835"/>
             <a:ext cx="1965960" cy="777240"/>
           </a:xfrm>
           <a:prstGeom prst="rect">
@@ -9278,7 +9841,7 @@
         </p:nvSpPr>
         <p:spPr>
           <a:xfrm>
-            <a:off x="7214616" y="2487168"/>
+            <a:off x="630936" y="4553458"/>
             <a:ext cx="1417320" cy="9144"/>
           </a:xfrm>
           <a:prstGeom prst="rect">
@@ -9294,6 +9857,10 @@
             <a:prstDash val="solid"/>
           </a:ln>
         </p:spPr>
+        <p:txBody>
+          <a:bodyPr/>
+          <a:p/>
+        </p:txBody>
       </p:sp>
       <p:sp>
         <p:nvSpPr>
@@ -9303,7 +9870,7 @@
         </p:nvSpPr>
         <p:spPr>
           <a:xfrm>
-            <a:off x="6940296" y="2542032"/>
+            <a:off x="411226" y="4564507"/>
             <a:ext cx="1965960" cy="274320"/>
           </a:xfrm>
           <a:prstGeom prst="rect">
@@ -9341,7 +9908,7 @@
         </p:nvSpPr>
         <p:spPr>
           <a:xfrm>
-            <a:off x="411480" y="2926080"/>
+            <a:off x="4055110" y="918210"/>
             <a:ext cx="4114800" cy="274320"/>
           </a:xfrm>
           <a:prstGeom prst="rect">
@@ -9387,7 +9954,7 @@
         </p:blipFill>
         <p:spPr>
           <a:xfrm>
-            <a:off x="411480" y="3246120"/>
+            <a:off x="4055110" y="1261745"/>
             <a:ext cx="3840480" cy="1645920"/>
           </a:xfrm>
           <a:prstGeom prst="rect">
@@ -9403,7 +9970,7 @@
         </p:nvSpPr>
         <p:spPr>
           <a:xfrm>
-            <a:off x="4754880" y="2926080"/>
+            <a:off x="4055110" y="2976880"/>
             <a:ext cx="4023360" cy="274320"/>
           </a:xfrm>
           <a:prstGeom prst="rect">
@@ -9441,7 +10008,7 @@
         </p:nvSpPr>
         <p:spPr>
           <a:xfrm>
-            <a:off x="4754880" y="3291840"/>
+            <a:off x="4055110" y="3252470"/>
             <a:ext cx="1371600" cy="320040"/>
           </a:xfrm>
           <a:prstGeom prst="rect">
@@ -9479,7 +10046,7 @@
         </p:nvSpPr>
         <p:spPr>
           <a:xfrm>
-            <a:off x="6217920" y="3364992"/>
+            <a:off x="4780280" y="3320542"/>
             <a:ext cx="2011680" cy="182880"/>
           </a:xfrm>
           <a:prstGeom prst="rect">
@@ -9495,6 +10062,10 @@
             <a:prstDash val="solid"/>
           </a:ln>
         </p:spPr>
+        <p:txBody>
+          <a:bodyPr/>
+          <a:p/>
+        </p:txBody>
       </p:sp>
       <p:sp>
         <p:nvSpPr>
@@ -9504,7 +10075,7 @@
         </p:nvSpPr>
         <p:spPr>
           <a:xfrm>
-            <a:off x="6217920" y="3364992"/>
+            <a:off x="4780280" y="3320542"/>
             <a:ext cx="2011680" cy="182880"/>
           </a:xfrm>
           <a:prstGeom prst="rect">
@@ -9520,6 +10091,10 @@
             <a:prstDash val="solid"/>
           </a:ln>
         </p:spPr>
+        <p:txBody>
+          <a:bodyPr/>
+          <a:p/>
+        </p:txBody>
       </p:sp>
       <p:sp>
         <p:nvSpPr>
@@ -9529,7 +10104,7 @@
         </p:nvSpPr>
         <p:spPr>
           <a:xfrm>
-            <a:off x="8321040" y="3291840"/>
+            <a:off x="6791960" y="3225165"/>
             <a:ext cx="457200" cy="320040"/>
           </a:xfrm>
           <a:prstGeom prst="rect">
@@ -9567,7 +10142,7 @@
         </p:nvSpPr>
         <p:spPr>
           <a:xfrm>
-            <a:off x="4754880" y="3685032"/>
+            <a:off x="4055110" y="3572637"/>
             <a:ext cx="1371600" cy="320040"/>
           </a:xfrm>
           <a:prstGeom prst="rect">
@@ -9605,7 +10180,7 @@
         </p:nvSpPr>
         <p:spPr>
           <a:xfrm>
-            <a:off x="6217920" y="3758184"/>
+            <a:off x="4780280" y="3678174"/>
             <a:ext cx="2011680" cy="182880"/>
           </a:xfrm>
           <a:prstGeom prst="rect">
@@ -9621,6 +10196,10 @@
             <a:prstDash val="solid"/>
           </a:ln>
         </p:spPr>
+        <p:txBody>
+          <a:bodyPr/>
+          <a:p/>
+        </p:txBody>
       </p:sp>
       <p:sp>
         <p:nvSpPr>
@@ -9630,7 +10209,7 @@
         </p:nvSpPr>
         <p:spPr>
           <a:xfrm>
-            <a:off x="6217920" y="3758184"/>
+            <a:off x="4780280" y="3678174"/>
             <a:ext cx="1810512" cy="182880"/>
           </a:xfrm>
           <a:prstGeom prst="rect">
@@ -9646,6 +10225,10 @@
             <a:prstDash val="solid"/>
           </a:ln>
         </p:spPr>
+        <p:txBody>
+          <a:bodyPr/>
+          <a:p/>
+        </p:txBody>
       </p:sp>
       <p:sp>
         <p:nvSpPr>
@@ -9655,7 +10238,7 @@
         </p:nvSpPr>
         <p:spPr>
           <a:xfrm>
-            <a:off x="8321040" y="3685032"/>
+            <a:off x="6791960" y="3545332"/>
             <a:ext cx="457200" cy="320040"/>
           </a:xfrm>
           <a:prstGeom prst="rect">
@@ -9693,7 +10276,7 @@
         </p:nvSpPr>
         <p:spPr>
           <a:xfrm>
-            <a:off x="4754880" y="4078224"/>
+            <a:off x="4055110" y="3862959"/>
             <a:ext cx="1371600" cy="320040"/>
           </a:xfrm>
           <a:prstGeom prst="rect">
@@ -9731,7 +10314,7 @@
         </p:nvSpPr>
         <p:spPr>
           <a:xfrm>
-            <a:off x="6217920" y="4151376"/>
+            <a:off x="4780280" y="3961511"/>
             <a:ext cx="2011680" cy="182880"/>
           </a:xfrm>
           <a:prstGeom prst="rect">
@@ -9747,6 +10330,10 @@
             <a:prstDash val="solid"/>
           </a:ln>
         </p:spPr>
+        <p:txBody>
+          <a:bodyPr/>
+          <a:p/>
+        </p:txBody>
       </p:sp>
       <p:sp>
         <p:nvSpPr>
@@ -9756,7 +10343,7 @@
         </p:nvSpPr>
         <p:spPr>
           <a:xfrm>
-            <a:off x="6217920" y="4151376"/>
+            <a:off x="4780280" y="3961511"/>
             <a:ext cx="1730045" cy="182880"/>
           </a:xfrm>
           <a:prstGeom prst="rect">
@@ -9772,6 +10359,10 @@
             <a:prstDash val="solid"/>
           </a:ln>
         </p:spPr>
+        <p:txBody>
+          <a:bodyPr/>
+          <a:p/>
+        </p:txBody>
       </p:sp>
       <p:sp>
         <p:nvSpPr>
@@ -9781,7 +10372,7 @@
         </p:nvSpPr>
         <p:spPr>
           <a:xfrm>
-            <a:off x="8321040" y="4078224"/>
+            <a:off x="6791960" y="3865499"/>
             <a:ext cx="457200" cy="320040"/>
           </a:xfrm>
           <a:prstGeom prst="rect">
@@ -9819,7 +10410,7 @@
         </p:nvSpPr>
         <p:spPr>
           <a:xfrm>
-            <a:off x="4754880" y="4471416"/>
+            <a:off x="4055110" y="4134866"/>
             <a:ext cx="1371600" cy="320040"/>
           </a:xfrm>
           <a:prstGeom prst="rect">
@@ -9857,7 +10448,7 @@
         </p:nvSpPr>
         <p:spPr>
           <a:xfrm>
-            <a:off x="6217920" y="4544568"/>
+            <a:off x="4780280" y="4245483"/>
             <a:ext cx="2011680" cy="182880"/>
           </a:xfrm>
           <a:prstGeom prst="rect">
@@ -9873,6 +10464,10 @@
             <a:prstDash val="solid"/>
           </a:ln>
         </p:spPr>
+        <p:txBody>
+          <a:bodyPr/>
+          <a:p/>
+        </p:txBody>
       </p:sp>
       <p:sp>
         <p:nvSpPr>
@@ -9882,7 +10477,7 @@
         </p:nvSpPr>
         <p:spPr>
           <a:xfrm>
-            <a:off x="6217920" y="4544568"/>
+            <a:off x="4780280" y="4245483"/>
             <a:ext cx="1669694" cy="182880"/>
           </a:xfrm>
           <a:prstGeom prst="rect">
@@ -9898,6 +10493,10 @@
             <a:prstDash val="solid"/>
           </a:ln>
         </p:spPr>
+        <p:txBody>
+          <a:bodyPr/>
+          <a:p/>
+        </p:txBody>
       </p:sp>
       <p:sp>
         <p:nvSpPr>
@@ -9907,7 +10506,7 @@
         </p:nvSpPr>
         <p:spPr>
           <a:xfrm>
-            <a:off x="8321040" y="4471416"/>
+            <a:off x="6791960" y="4141851"/>
             <a:ext cx="457200" cy="320040"/>
           </a:xfrm>
           <a:prstGeom prst="rect">
@@ -10032,6 +10631,10 @@
             <a:prstDash val="solid"/>
           </a:ln>
         </p:spPr>
+        <p:txBody>
+          <a:bodyPr/>
+          <a:p/>
+        </p:txBody>
       </p:sp>
       <p:sp>
         <p:nvSpPr>
@@ -10196,7 +10799,7 @@
             <a:r>
               <a:rPr lang="en-US" sz="1200" dirty="0">
                 <a:solidFill>
-                  <a:srgbClr val="888888"/>
+                  <a:schemeClr val="tx1"/>
                 </a:solidFill>
                 <a:latin typeface="Georgia" panose="02040502050405020303" pitchFamily="34" charset="0"/>
                 <a:ea typeface="Georgia" panose="02040502050405020303" pitchFamily="34" charset="-122"/>
@@ -10204,7 +10807,14 @@
               </a:rPr>
               <a:t>Cử chỉ đặc trưng, nhận diện hoàn hảo</a:t>
             </a:r>
-            <a:endParaRPr lang="en-US" sz="1200" dirty="0"/>
+            <a:endParaRPr lang="en-US" sz="1200" dirty="0">
+              <a:solidFill>
+                <a:schemeClr val="tx1"/>
+              </a:solidFill>
+              <a:latin typeface="Georgia" panose="02040502050405020303" pitchFamily="34" charset="0"/>
+              <a:ea typeface="Georgia" panose="02040502050405020303" pitchFamily="34" charset="-122"/>
+              <a:cs typeface="Georgia" panose="02040502050405020303" pitchFamily="34" charset="-120"/>
+            </a:endParaRPr>
           </a:p>
         </p:txBody>
       </p:sp>
@@ -10232,6 +10842,10 @@
             <a:prstDash val="solid"/>
           </a:ln>
         </p:spPr>
+        <p:txBody>
+          <a:bodyPr/>
+          <a:p/>
+        </p:txBody>
       </p:sp>
       <p:sp>
         <p:nvSpPr>
@@ -10335,7 +10949,7 @@
             <a:r>
               <a:rPr lang="en-US" sz="1200" dirty="0">
                 <a:solidFill>
-                  <a:srgbClr val="888888"/>
+                  <a:schemeClr val="tx1"/>
                 </a:solidFill>
                 <a:latin typeface="Georgia" panose="02040502050405020303" pitchFamily="34" charset="0"/>
                 <a:ea typeface="Georgia" panose="02040502050405020303" pitchFamily="34" charset="-122"/>
@@ -10343,7 +10957,14 @@
               </a:rPr>
               <a:t>Tốt – một số mẫu NO bị nhầm sang nhãn này</a:t>
             </a:r>
-            <a:endParaRPr lang="en-US" sz="1200" dirty="0"/>
+            <a:endParaRPr lang="en-US" sz="1200" dirty="0">
+              <a:solidFill>
+                <a:schemeClr val="tx1"/>
+              </a:solidFill>
+              <a:latin typeface="Georgia" panose="02040502050405020303" pitchFamily="34" charset="0"/>
+              <a:ea typeface="Georgia" panose="02040502050405020303" pitchFamily="34" charset="-122"/>
+              <a:cs typeface="Georgia" panose="02040502050405020303" pitchFamily="34" charset="-120"/>
+            </a:endParaRPr>
           </a:p>
         </p:txBody>
       </p:sp>
@@ -10371,6 +10992,10 @@
             <a:prstDash val="solid"/>
           </a:ln>
         </p:spPr>
+        <p:txBody>
+          <a:bodyPr/>
+          <a:p/>
+        </p:txBody>
       </p:sp>
       <p:sp>
         <p:nvSpPr>
@@ -10474,7 +11099,7 @@
             <a:r>
               <a:rPr lang="en-US" sz="1200" dirty="0">
                 <a:solidFill>
-                  <a:srgbClr val="888888"/>
+                  <a:schemeClr val="tx1"/>
                 </a:solidFill>
                 <a:latin typeface="Georgia" panose="02040502050405020303" pitchFamily="34" charset="0"/>
                 <a:ea typeface="Georgia" panose="02040502050405020303" pitchFamily="34" charset="-122"/>
@@ -10482,7 +11107,14 @@
               </a:rPr>
               <a:t>18.2% bị nhầm sang XINCHAO</a:t>
             </a:r>
-            <a:endParaRPr lang="en-US" sz="1200" dirty="0"/>
+            <a:endParaRPr lang="en-US" sz="1200" dirty="0">
+              <a:solidFill>
+                <a:schemeClr val="tx1"/>
+              </a:solidFill>
+              <a:latin typeface="Georgia" panose="02040502050405020303" pitchFamily="34" charset="0"/>
+              <a:ea typeface="Georgia" panose="02040502050405020303" pitchFamily="34" charset="-122"/>
+              <a:cs typeface="Georgia" panose="02040502050405020303" pitchFamily="34" charset="-120"/>
+            </a:endParaRPr>
           </a:p>
         </p:txBody>
       </p:sp>
@@ -10510,6 +11142,10 @@
             <a:prstDash val="solid"/>
           </a:ln>
         </p:spPr>
+        <p:txBody>
+          <a:bodyPr/>
+          <a:p/>
+        </p:txBody>
       </p:sp>
       <p:sp>
         <p:nvSpPr>
@@ -10613,7 +11249,7 @@
             <a:r>
               <a:rPr lang="en-US" sz="1200" dirty="0">
                 <a:solidFill>
-                  <a:srgbClr val="888888"/>
+                  <a:schemeClr val="tx1"/>
                 </a:solidFill>
                 <a:latin typeface="Georgia" panose="02040502050405020303" pitchFamily="34" charset="0"/>
                 <a:ea typeface="Georgia" panose="02040502050405020303" pitchFamily="34" charset="-122"/>
@@ -10621,7 +11257,14 @@
               </a:rPr>
               <a:t>28.6% bị nhầm sang XINCHAO – lỗi chính</a:t>
             </a:r>
-            <a:endParaRPr lang="en-US" sz="1200" dirty="0"/>
+            <a:endParaRPr lang="en-US" sz="1200" dirty="0">
+              <a:solidFill>
+                <a:schemeClr val="tx1"/>
+              </a:solidFill>
+              <a:latin typeface="Georgia" panose="02040502050405020303" pitchFamily="34" charset="0"/>
+              <a:ea typeface="Georgia" panose="02040502050405020303" pitchFamily="34" charset="-122"/>
+              <a:cs typeface="Georgia" panose="02040502050405020303" pitchFamily="34" charset="-120"/>
+            </a:endParaRPr>
           </a:p>
         </p:txBody>
       </p:sp>
@@ -10649,6 +11292,10 @@
             <a:prstDash val="solid"/>
           </a:ln>
         </p:spPr>
+        <p:txBody>
+          <a:bodyPr/>
+          <a:p/>
+        </p:txBody>
       </p:sp>
       <p:sp>
         <p:nvSpPr>
@@ -10679,7 +11326,7 @@
             <a:r>
               <a:rPr lang="en-US" sz="1100" dirty="0">
                 <a:solidFill>
-                  <a:srgbClr val="888888"/>
+                  <a:schemeClr val="tx1"/>
                 </a:solidFill>
                 <a:latin typeface="Georgia" panose="02040502050405020303" pitchFamily="34" charset="0"/>
                 <a:ea typeface="Georgia" panose="02040502050405020303" pitchFamily="34" charset="-122"/>
@@ -10687,7 +11334,11 @@
               </a:rPr>
               <a:t>Nguyên nhân lỗi chính: NO và XINCHAO đều là bàn tay mở → hình dạng tương tự.</a:t>
             </a:r>
-            <a:endParaRPr lang="en-US" sz="1100" dirty="0"/>
+            <a:endParaRPr lang="en-US" sz="1100" dirty="0">
+              <a:solidFill>
+                <a:schemeClr val="tx1"/>
+              </a:solidFill>
+            </a:endParaRPr>
           </a:p>
           <a:p>
             <a:pPr marL="0" indent="0">
@@ -10699,7 +11350,7 @@
             <a:r>
               <a:rPr lang="en-US" sz="1100" dirty="0">
                 <a:solidFill>
-                  <a:srgbClr val="888888"/>
+                  <a:schemeClr val="tx1"/>
                 </a:solidFill>
                 <a:latin typeface="Georgia" panose="02040502050405020303" pitchFamily="34" charset="0"/>
                 <a:ea typeface="Georgia" panose="02040502050405020303" pitchFamily="34" charset="-122"/>
@@ -10707,7 +11358,14 @@
               </a:rPr>
               <a:t>Cần thu thêm mẫu NO đa dạng góc độ hơn để cải thiện.</a:t>
             </a:r>
-            <a:endParaRPr lang="en-US" sz="1100" dirty="0"/>
+            <a:endParaRPr lang="en-US" sz="1100" dirty="0">
+              <a:solidFill>
+                <a:schemeClr val="tx1"/>
+              </a:solidFill>
+              <a:latin typeface="Georgia" panose="02040502050405020303" pitchFamily="34" charset="0"/>
+              <a:ea typeface="Georgia" panose="02040502050405020303" pitchFamily="34" charset="-122"/>
+              <a:cs typeface="Georgia" panose="02040502050405020303" pitchFamily="34" charset="-120"/>
+            </a:endParaRPr>
           </a:p>
         </p:txBody>
       </p:sp>

</xml_diff>